<commit_message>
feat: add a new figure for housing configuration in two scenarios where P = 6, S = 3
</commit_message>
<xml_diff>
--- a/images-for-proof.pptx
+++ b/images-for-proof.pptx
@@ -10,10 +10,12 @@
     <p:sldId id="265" r:id="rId4"/>
     <p:sldId id="260" r:id="rId5"/>
     <p:sldId id="261" r:id="rId6"/>
-    <p:sldId id="266" r:id="rId7"/>
-    <p:sldId id="259" r:id="rId8"/>
-    <p:sldId id="262" r:id="rId9"/>
-    <p:sldId id="263" r:id="rId10"/>
+    <p:sldId id="267" r:id="rId7"/>
+    <p:sldId id="266" r:id="rId8"/>
+    <p:sldId id="259" r:id="rId9"/>
+    <p:sldId id="262" r:id="rId10"/>
+    <p:sldId id="263" r:id="rId11"/>
+    <p:sldId id="268" r:id="rId12"/>
   </p:sldIdLst>
   <p:sldSz cx="12192000" cy="6858000"/>
   <p:notesSz cx="6858000" cy="9144000"/>
@@ -267,7 +269,7 @@
           <a:p>
             <a:fld id="{80B7F96D-77AA-4333-BC36-470FA2610C7E}" type="datetimeFigureOut">
               <a:rPr lang="en-US" smtClean="0"/>
-              <a:t>3/31/2025</a:t>
+              <a:t>5/20/2025</a:t>
             </a:fld>
             <a:endParaRPr lang="en-US"/>
           </a:p>
@@ -465,7 +467,7 @@
           <a:p>
             <a:fld id="{80B7F96D-77AA-4333-BC36-470FA2610C7E}" type="datetimeFigureOut">
               <a:rPr lang="en-US" smtClean="0"/>
-              <a:t>3/31/2025</a:t>
+              <a:t>5/20/2025</a:t>
             </a:fld>
             <a:endParaRPr lang="en-US"/>
           </a:p>
@@ -673,7 +675,7 @@
           <a:p>
             <a:fld id="{80B7F96D-77AA-4333-BC36-470FA2610C7E}" type="datetimeFigureOut">
               <a:rPr lang="en-US" smtClean="0"/>
-              <a:t>3/31/2025</a:t>
+              <a:t>5/20/2025</a:t>
             </a:fld>
             <a:endParaRPr lang="en-US"/>
           </a:p>
@@ -871,7 +873,7 @@
           <a:p>
             <a:fld id="{80B7F96D-77AA-4333-BC36-470FA2610C7E}" type="datetimeFigureOut">
               <a:rPr lang="en-US" smtClean="0"/>
-              <a:t>3/31/2025</a:t>
+              <a:t>5/20/2025</a:t>
             </a:fld>
             <a:endParaRPr lang="en-US"/>
           </a:p>
@@ -1146,7 +1148,7 @@
           <a:p>
             <a:fld id="{80B7F96D-77AA-4333-BC36-470FA2610C7E}" type="datetimeFigureOut">
               <a:rPr lang="en-US" smtClean="0"/>
-              <a:t>3/31/2025</a:t>
+              <a:t>5/20/2025</a:t>
             </a:fld>
             <a:endParaRPr lang="en-US"/>
           </a:p>
@@ -1411,7 +1413,7 @@
           <a:p>
             <a:fld id="{80B7F96D-77AA-4333-BC36-470FA2610C7E}" type="datetimeFigureOut">
               <a:rPr lang="en-US" smtClean="0"/>
-              <a:t>3/31/2025</a:t>
+              <a:t>5/20/2025</a:t>
             </a:fld>
             <a:endParaRPr lang="en-US"/>
           </a:p>
@@ -1823,7 +1825,7 @@
           <a:p>
             <a:fld id="{80B7F96D-77AA-4333-BC36-470FA2610C7E}" type="datetimeFigureOut">
               <a:rPr lang="en-US" smtClean="0"/>
-              <a:t>3/31/2025</a:t>
+              <a:t>5/20/2025</a:t>
             </a:fld>
             <a:endParaRPr lang="en-US"/>
           </a:p>
@@ -1964,7 +1966,7 @@
           <a:p>
             <a:fld id="{80B7F96D-77AA-4333-BC36-470FA2610C7E}" type="datetimeFigureOut">
               <a:rPr lang="en-US" smtClean="0"/>
-              <a:t>3/31/2025</a:t>
+              <a:t>5/20/2025</a:t>
             </a:fld>
             <a:endParaRPr lang="en-US"/>
           </a:p>
@@ -2077,7 +2079,7 @@
           <a:p>
             <a:fld id="{80B7F96D-77AA-4333-BC36-470FA2610C7E}" type="datetimeFigureOut">
               <a:rPr lang="en-US" smtClean="0"/>
-              <a:t>3/31/2025</a:t>
+              <a:t>5/20/2025</a:t>
             </a:fld>
             <a:endParaRPr lang="en-US"/>
           </a:p>
@@ -2388,7 +2390,7 @@
           <a:p>
             <a:fld id="{80B7F96D-77AA-4333-BC36-470FA2610C7E}" type="datetimeFigureOut">
               <a:rPr lang="en-US" smtClean="0"/>
-              <a:t>3/31/2025</a:t>
+              <a:t>5/20/2025</a:t>
             </a:fld>
             <a:endParaRPr lang="en-US"/>
           </a:p>
@@ -2676,7 +2678,7 @@
           <a:p>
             <a:fld id="{80B7F96D-77AA-4333-BC36-470FA2610C7E}" type="datetimeFigureOut">
               <a:rPr lang="en-US" smtClean="0"/>
-              <a:t>3/31/2025</a:t>
+              <a:t>5/20/2025</a:t>
             </a:fld>
             <a:endParaRPr lang="en-US"/>
           </a:p>
@@ -2917,7 +2919,7 @@
           <a:p>
             <a:fld id="{80B7F96D-77AA-4333-BC36-470FA2610C7E}" type="datetimeFigureOut">
               <a:rPr lang="en-US" smtClean="0"/>
-              <a:t>3/31/2025</a:t>
+              <a:t>5/20/2025</a:t>
             </a:fld>
             <a:endParaRPr lang="en-US"/>
           </a:p>
@@ -4387,6 +4389,286 @@
 </p:sld>
 </file>
 
+<file path=ppt/slides/slide10.xml><?xml version="1.0" encoding="utf-8"?>
+<p:sld xmlns:a="http://schemas.openxmlformats.org/drawingml/2006/main" xmlns:r="http://schemas.openxmlformats.org/officeDocument/2006/relationships" xmlns:p="http://schemas.openxmlformats.org/presentationml/2006/main">
+  <p:cSld>
+    <p:spTree>
+      <p:nvGrpSpPr>
+        <p:cNvPr id="1" name=""/>
+        <p:cNvGrpSpPr/>
+        <p:nvPr/>
+      </p:nvGrpSpPr>
+      <p:grpSpPr>
+        <a:xfrm>
+          <a:off x="0" y="0"/>
+          <a:ext cx="0" cy="0"/>
+          <a:chOff x="0" y="0"/>
+          <a:chExt cx="0" cy="0"/>
+        </a:xfrm>
+      </p:grpSpPr>
+      <p:pic>
+        <p:nvPicPr>
+          <p:cNvPr id="2" name="Picture 1">
+            <a:extLst>
+              <a:ext uri="{FF2B5EF4-FFF2-40B4-BE49-F238E27FC236}">
+                <a16:creationId xmlns:a16="http://schemas.microsoft.com/office/drawing/2014/main" id="{ABAE4FC8-574C-CC7A-A384-74DAF20ED743}"/>
+              </a:ext>
+            </a:extLst>
+          </p:cNvPr>
+          <p:cNvPicPr>
+            <a:picLocks noChangeAspect="1"/>
+          </p:cNvPicPr>
+          <p:nvPr/>
+        </p:nvPicPr>
+        <p:blipFill>
+          <a:blip r:embed="rId2"/>
+          <a:stretch>
+            <a:fillRect/>
+          </a:stretch>
+        </p:blipFill>
+        <p:spPr>
+          <a:xfrm>
+            <a:off x="1852816" y="2038991"/>
+            <a:ext cx="8486368" cy="2780017"/>
+          </a:xfrm>
+          <a:prstGeom prst="rect">
+            <a:avLst/>
+          </a:prstGeom>
+        </p:spPr>
+      </p:pic>
+      <mc:AlternateContent xmlns:mc="http://schemas.openxmlformats.org/markup-compatibility/2006" xmlns:a14="http://schemas.microsoft.com/office/drawing/2010/main">
+        <mc:Choice Requires="a14">
+          <p:sp>
+            <p:nvSpPr>
+              <p:cNvPr id="3" name="TextBox 2">
+                <a:extLst>
+                  <a:ext uri="{FF2B5EF4-FFF2-40B4-BE49-F238E27FC236}">
+                    <a16:creationId xmlns:a16="http://schemas.microsoft.com/office/drawing/2014/main" id="{8C943BC5-80E7-C591-97D0-21663D439FB8}"/>
+                  </a:ext>
+                </a:extLst>
+              </p:cNvPr>
+              <p:cNvSpPr txBox="1"/>
+              <p:nvPr/>
+            </p:nvSpPr>
+            <p:spPr>
+              <a:xfrm>
+                <a:off x="659561" y="1203559"/>
+                <a:ext cx="5293629" cy="553998"/>
+              </a:xfrm>
+              <a:prstGeom prst="rect">
+                <a:avLst/>
+              </a:prstGeom>
+              <a:noFill/>
+            </p:spPr>
+            <p:txBody>
+              <a:bodyPr wrap="none" lIns="0" tIns="0" rIns="0" bIns="0" rtlCol="0">
+                <a:spAutoFit/>
+              </a:bodyPr>
+              <a:lstStyle/>
+              <a:p>
+                <a14:m>
+                  <m:oMath xmlns:m="http://schemas.openxmlformats.org/officeDocument/2006/math">
+                    <m:sSub>
+                      <m:sSubPr>
+                        <m:ctrlPr>
+                          <a:rPr lang="en-US" sz="3600" b="0" i="1" smtClean="0">
+                            <a:latin typeface="Cambria Math" panose="02040503050406030204" pitchFamily="18" charset="0"/>
+                          </a:rPr>
+                        </m:ctrlPr>
+                      </m:sSubPr>
+                      <m:e>
+                        <m:r>
+                          <a:rPr lang="en-US" sz="3600" b="0" i="1" smtClean="0">
+                            <a:latin typeface="Cambria Math" panose="02040503050406030204" pitchFamily="18" charset="0"/>
+                          </a:rPr>
+                          <m:t>𝑚</m:t>
+                        </m:r>
+                      </m:e>
+                      <m:sub>
+                        <m:r>
+                          <a:rPr lang="en-US" sz="3600" b="0" i="1" smtClean="0">
+                            <a:latin typeface="Cambria Math" panose="02040503050406030204" pitchFamily="18" charset="0"/>
+                          </a:rPr>
+                          <m:t>𝑘</m:t>
+                        </m:r>
+                        <m:r>
+                          <a:rPr lang="en-US" sz="3600" b="0" i="1" smtClean="0">
+                            <a:latin typeface="Cambria Math" panose="02040503050406030204" pitchFamily="18" charset="0"/>
+                          </a:rPr>
+                          <m:t>+1</m:t>
+                        </m:r>
+                      </m:sub>
+                    </m:sSub>
+                    <m:r>
+                      <a:rPr lang="en-US" sz="3600" b="0" i="1" smtClean="0">
+                        <a:latin typeface="Cambria Math" panose="02040503050406030204" pitchFamily="18" charset="0"/>
+                      </a:rPr>
+                      <m:t>&lt;</m:t>
+                    </m:r>
+                    <m:sSub>
+                      <m:sSubPr>
+                        <m:ctrlPr>
+                          <a:rPr lang="en-US" sz="3600" b="0" i="1" smtClean="0">
+                            <a:latin typeface="Cambria Math" panose="02040503050406030204" pitchFamily="18" charset="0"/>
+                          </a:rPr>
+                        </m:ctrlPr>
+                      </m:sSubPr>
+                      <m:e>
+                        <m:r>
+                          <a:rPr lang="en-US" sz="3600" b="0" i="1" smtClean="0">
+                            <a:latin typeface="Cambria Math" panose="02040503050406030204" pitchFamily="18" charset="0"/>
+                          </a:rPr>
+                          <m:t>𝑚</m:t>
+                        </m:r>
+                      </m:e>
+                      <m:sub>
+                        <m:r>
+                          <a:rPr lang="en-US" sz="3600" b="0" i="1" smtClean="0">
+                            <a:latin typeface="Cambria Math" panose="02040503050406030204" pitchFamily="18" charset="0"/>
+                          </a:rPr>
+                          <m:t>𝑘</m:t>
+                        </m:r>
+                      </m:sub>
+                    </m:sSub>
+                    <m:r>
+                      <a:rPr lang="en-US" sz="3600" b="0" i="1" smtClean="0">
+                        <a:latin typeface="Cambria Math" panose="02040503050406030204" pitchFamily="18" charset="0"/>
+                      </a:rPr>
+                      <m:t>−1</m:t>
+                    </m:r>
+                  </m:oMath>
+                </a14:m>
+                <a:r>
+                  <a:rPr lang="en-US" sz="3600" dirty="0"/>
+                  <a:t> </a:t>
+                </a:r>
+                <a:r>
+                  <a:rPr lang="en-US" sz="3600"/>
+                  <a:t>(figure 1.5)</a:t>
+                </a:r>
+                <a:endParaRPr lang="en-US" sz="3600" dirty="0"/>
+              </a:p>
+            </p:txBody>
+          </p:sp>
+        </mc:Choice>
+        <mc:Fallback xmlns="">
+          <p:sp>
+            <p:nvSpPr>
+              <p:cNvPr id="3" name="TextBox 2">
+                <a:extLst>
+                  <a:ext uri="{FF2B5EF4-FFF2-40B4-BE49-F238E27FC236}">
+                    <a16:creationId xmlns:a16="http://schemas.microsoft.com/office/drawing/2014/main" id="{8C943BC5-80E7-C591-97D0-21663D439FB8}"/>
+                  </a:ext>
+                </a:extLst>
+              </p:cNvPr>
+              <p:cNvSpPr txBox="1">
+                <a:spLocks noRot="1" noChangeAspect="1" noMove="1" noResize="1" noEditPoints="1" noAdjustHandles="1" noChangeArrowheads="1" noChangeShapeType="1" noTextEdit="1"/>
+              </p:cNvSpPr>
+              <p:nvPr/>
+            </p:nvSpPr>
+            <p:spPr>
+              <a:xfrm>
+                <a:off x="659561" y="1203559"/>
+                <a:ext cx="5293629" cy="553998"/>
+              </a:xfrm>
+              <a:prstGeom prst="rect">
+                <a:avLst/>
+              </a:prstGeom>
+              <a:blipFill>
+                <a:blip r:embed="rId3"/>
+                <a:stretch>
+                  <a:fillRect t="-24176" r="-4143" b="-50549"/>
+                </a:stretch>
+              </a:blipFill>
+            </p:spPr>
+            <p:txBody>
+              <a:bodyPr/>
+              <a:lstStyle/>
+              <a:p>
+                <a:r>
+                  <a:rPr lang="en-US">
+                    <a:noFill/>
+                  </a:rPr>
+                  <a:t> </a:t>
+                </a:r>
+              </a:p>
+            </p:txBody>
+          </p:sp>
+        </mc:Fallback>
+      </mc:AlternateContent>
+    </p:spTree>
+    <p:extLst>
+      <p:ext uri="{BB962C8B-B14F-4D97-AF65-F5344CB8AC3E}">
+        <p14:creationId xmlns:p14="http://schemas.microsoft.com/office/powerpoint/2010/main" val="2681676662"/>
+      </p:ext>
+    </p:extLst>
+  </p:cSld>
+  <p:clrMapOvr>
+    <a:masterClrMapping/>
+  </p:clrMapOvr>
+</p:sld>
+</file>
+
+<file path=ppt/slides/slide11.xml><?xml version="1.0" encoding="utf-8"?>
+<p:sld xmlns:a="http://schemas.openxmlformats.org/drawingml/2006/main" xmlns:r="http://schemas.openxmlformats.org/officeDocument/2006/relationships" xmlns:p="http://schemas.openxmlformats.org/presentationml/2006/main">
+  <p:cSld>
+    <p:spTree>
+      <p:nvGrpSpPr>
+        <p:cNvPr id="1" name=""/>
+        <p:cNvGrpSpPr/>
+        <p:nvPr/>
+      </p:nvGrpSpPr>
+      <p:grpSpPr>
+        <a:xfrm>
+          <a:off x="0" y="0"/>
+          <a:ext cx="0" cy="0"/>
+          <a:chOff x="0" y="0"/>
+          <a:chExt cx="0" cy="0"/>
+        </a:xfrm>
+      </p:grpSpPr>
+      <p:pic>
+        <p:nvPicPr>
+          <p:cNvPr id="2" name="Picture 1">
+            <a:extLst>
+              <a:ext uri="{FF2B5EF4-FFF2-40B4-BE49-F238E27FC236}">
+                <a16:creationId xmlns:a16="http://schemas.microsoft.com/office/drawing/2014/main" id="{7CEDA076-9C75-9080-25B2-D8BD2373392F}"/>
+              </a:ext>
+            </a:extLst>
+          </p:cNvPr>
+          <p:cNvPicPr>
+            <a:picLocks noChangeAspect="1"/>
+          </p:cNvPicPr>
+          <p:nvPr/>
+        </p:nvPicPr>
+        <p:blipFill>
+          <a:blip r:embed="rId2"/>
+          <a:stretch>
+            <a:fillRect/>
+          </a:stretch>
+        </p:blipFill>
+        <p:spPr>
+          <a:xfrm>
+            <a:off x="1072460" y="1889626"/>
+            <a:ext cx="10047079" cy="3078747"/>
+          </a:xfrm>
+          <a:prstGeom prst="rect">
+            <a:avLst/>
+          </a:prstGeom>
+        </p:spPr>
+      </p:pic>
+    </p:spTree>
+    <p:extLst>
+      <p:ext uri="{BB962C8B-B14F-4D97-AF65-F5344CB8AC3E}">
+        <p14:creationId xmlns:p14="http://schemas.microsoft.com/office/powerpoint/2010/main" val="4238699699"/>
+      </p:ext>
+    </p:extLst>
+  </p:cSld>
+  <p:clrMapOvr>
+    <a:masterClrMapping/>
+  </p:clrMapOvr>
+</p:sld>
+</file>
+
 <file path=ppt/slides/slide2.xml><?xml version="1.0" encoding="utf-8"?>
 <p:sld xmlns:a="http://schemas.openxmlformats.org/drawingml/2006/main" xmlns:r="http://schemas.openxmlformats.org/officeDocument/2006/relationships" xmlns:p="http://schemas.openxmlformats.org/presentationml/2006/main">
   <p:cSld>
@@ -4462,8 +4744,8 @@
           </a:p>
         </p:txBody>
       </p:sp>
-      <mc:AlternateContent xmlns:mc="http://schemas.openxmlformats.org/markup-compatibility/2006">
-        <mc:Choice xmlns:a14="http://schemas.microsoft.com/office/drawing/2010/main" Requires="a14">
+      <mc:AlternateContent xmlns:mc="http://schemas.openxmlformats.org/markup-compatibility/2006" xmlns:a14="http://schemas.microsoft.com/office/drawing/2010/main">
+        <mc:Choice Requires="a14">
           <p:sp>
             <p:nvSpPr>
               <p:cNvPr id="32" name="TextBox 31">
@@ -4519,7 +4801,7 @@
             </p:txBody>
           </p:sp>
         </mc:Choice>
-        <mc:Fallback>
+        <mc:Fallback xmlns="">
           <p:sp>
             <p:nvSpPr>
               <p:cNvPr id="32" name="TextBox 31">
@@ -4564,8 +4846,8 @@
           </p:sp>
         </mc:Fallback>
       </mc:AlternateContent>
-      <mc:AlternateContent xmlns:mc="http://schemas.openxmlformats.org/markup-compatibility/2006">
-        <mc:Choice xmlns:a14="http://schemas.microsoft.com/office/drawing/2010/main" Requires="a14">
+      <mc:AlternateContent xmlns:mc="http://schemas.openxmlformats.org/markup-compatibility/2006" xmlns:a14="http://schemas.microsoft.com/office/drawing/2010/main">
+        <mc:Choice Requires="a14">
           <p:sp>
             <p:nvSpPr>
               <p:cNvPr id="33" name="TextBox 32">
@@ -4621,7 +4903,7 @@
             </p:txBody>
           </p:sp>
         </mc:Choice>
-        <mc:Fallback>
+        <mc:Fallback xmlns="">
           <p:sp>
             <p:nvSpPr>
               <p:cNvPr id="33" name="TextBox 32">
@@ -4694,7 +4976,6 @@
           </a:bodyPr>
           <a:lstStyle/>
           <a:p>
-            <a:pPr/>
             <a:r>
               <a:rPr lang="en-US" sz="3600" dirty="0"/>
               <a:t>Person-level average household size</a:t>
@@ -4702,8 +4983,8 @@
           </a:p>
         </p:txBody>
       </p:sp>
-      <mc:AlternateContent xmlns:mc="http://schemas.openxmlformats.org/markup-compatibility/2006">
-        <mc:Choice xmlns:a14="http://schemas.microsoft.com/office/drawing/2010/main" Requires="a14">
+      <mc:AlternateContent xmlns:mc="http://schemas.openxmlformats.org/markup-compatibility/2006" xmlns:a14="http://schemas.microsoft.com/office/drawing/2010/main">
+        <mc:Choice Requires="a14">
           <p:sp>
             <p:nvSpPr>
               <p:cNvPr id="12" name="TextBox 11">
@@ -4768,13 +5049,7 @@
                         <a:rPr lang="en-US" sz="1600" b="0" i="1" smtClean="0">
                           <a:latin typeface="Cambria Math" panose="02040503050406030204" pitchFamily="18" charset="0"/>
                         </a:rPr>
-                        <m:t>=</m:t>
-                      </m:r>
-                      <m:r>
-                        <a:rPr lang="en-US" sz="1600" b="0" i="1" smtClean="0">
-                          <a:latin typeface="Cambria Math" panose="02040503050406030204" pitchFamily="18" charset="0"/>
-                        </a:rPr>
-                        <m:t>3</m:t>
+                        <m:t>=3</m:t>
                       </m:r>
                     </m:oMath>
                   </m:oMathPara>
@@ -4784,7 +5059,7 @@
             </p:txBody>
           </p:sp>
         </mc:Choice>
-        <mc:Fallback>
+        <mc:Fallback xmlns="">
           <p:sp>
             <p:nvSpPr>
               <p:cNvPr id="12" name="TextBox 11">
@@ -5037,8 +5312,8 @@
           </a:p>
         </p:txBody>
       </p:sp>
-      <mc:AlternateContent xmlns:mc="http://schemas.openxmlformats.org/markup-compatibility/2006">
-        <mc:Choice xmlns:a14="http://schemas.microsoft.com/office/drawing/2010/main" Requires="a14">
+      <mc:AlternateContent xmlns:mc="http://schemas.openxmlformats.org/markup-compatibility/2006" xmlns:a14="http://schemas.microsoft.com/office/drawing/2010/main">
+        <mc:Choice Requires="a14">
           <p:sp>
             <p:nvSpPr>
               <p:cNvPr id="24" name="TextBox 23">
@@ -5103,13 +5378,7 @@
                         <a:rPr lang="en-US" sz="1600" b="0" i="1" smtClean="0">
                           <a:latin typeface="Cambria Math" panose="02040503050406030204" pitchFamily="18" charset="0"/>
                         </a:rPr>
-                        <m:t>=</m:t>
-                      </m:r>
-                      <m:r>
-                        <a:rPr lang="en-US" sz="1600" b="0" i="1" smtClean="0">
-                          <a:latin typeface="Cambria Math" panose="02040503050406030204" pitchFamily="18" charset="0"/>
-                        </a:rPr>
-                        <m:t>1</m:t>
+                        <m:t>=1</m:t>
                       </m:r>
                     </m:oMath>
                   </m:oMathPara>
@@ -5119,7 +5388,7 @@
             </p:txBody>
           </p:sp>
         </mc:Choice>
-        <mc:Fallback>
+        <mc:Fallback xmlns="">
           <p:sp>
             <p:nvSpPr>
               <p:cNvPr id="24" name="TextBox 23">
@@ -5164,8 +5433,8 @@
           </p:sp>
         </mc:Fallback>
       </mc:AlternateContent>
-      <mc:AlternateContent xmlns:mc="http://schemas.openxmlformats.org/markup-compatibility/2006">
-        <mc:Choice xmlns:a14="http://schemas.microsoft.com/office/drawing/2010/main" Requires="a14">
+      <mc:AlternateContent xmlns:mc="http://schemas.openxmlformats.org/markup-compatibility/2006" xmlns:a14="http://schemas.microsoft.com/office/drawing/2010/main">
+        <mc:Choice Requires="a14">
           <p:sp>
             <p:nvSpPr>
               <p:cNvPr id="25" name="TextBox 24">
@@ -5194,6 +5463,7 @@
               </a:bodyPr>
               <a:lstStyle/>
               <a:p>
+                <a:pPr/>
                 <a14:m>
                   <m:oMathPara xmlns:m="http://schemas.openxmlformats.org/officeDocument/2006/math">
                     <m:oMathParaPr>
@@ -5264,7 +5534,7 @@
             </p:txBody>
           </p:sp>
         </mc:Choice>
-        <mc:Fallback>
+        <mc:Fallback xmlns="">
           <p:sp>
             <p:nvSpPr>
               <p:cNvPr id="25" name="TextBox 24">
@@ -12287,6 +12557,1946 @@
   <p:cSld>
     <p:spTree>
       <p:nvGrpSpPr>
+        <p:cNvPr id="1" name="">
+          <a:extLst>
+            <a:ext uri="{FF2B5EF4-FFF2-40B4-BE49-F238E27FC236}">
+              <a16:creationId xmlns:a16="http://schemas.microsoft.com/office/drawing/2014/main" id="{D8CF23BE-C120-C9A1-1502-F7425316E44A}"/>
+            </a:ext>
+          </a:extLst>
+        </p:cNvPr>
+        <p:cNvGrpSpPr/>
+        <p:nvPr/>
+      </p:nvGrpSpPr>
+      <p:grpSpPr>
+        <a:xfrm>
+          <a:off x="0" y="0"/>
+          <a:ext cx="0" cy="0"/>
+          <a:chOff x="0" y="0"/>
+          <a:chExt cx="0" cy="0"/>
+        </a:xfrm>
+      </p:grpSpPr>
+      <p:sp>
+        <p:nvSpPr>
+          <p:cNvPr id="19" name="Rectangle 18">
+            <a:extLst>
+              <a:ext uri="{FF2B5EF4-FFF2-40B4-BE49-F238E27FC236}">
+                <a16:creationId xmlns:a16="http://schemas.microsoft.com/office/drawing/2014/main" id="{788EF696-9CC7-B3CF-6DB6-899647CCA9A3}"/>
+              </a:ext>
+            </a:extLst>
+          </p:cNvPr>
+          <p:cNvSpPr/>
+          <p:nvPr/>
+        </p:nvSpPr>
+        <p:spPr>
+          <a:xfrm>
+            <a:off x="1346195" y="3197219"/>
+            <a:ext cx="1371600" cy="1411550"/>
+          </a:xfrm>
+          <a:prstGeom prst="rect">
+            <a:avLst/>
+          </a:prstGeom>
+          <a:noFill/>
+          <a:ln>
+            <a:solidFill>
+              <a:schemeClr val="tx1"/>
+            </a:solidFill>
+          </a:ln>
+        </p:spPr>
+        <p:style>
+          <a:lnRef idx="2">
+            <a:schemeClr val="accent1">
+              <a:shade val="15000"/>
+            </a:schemeClr>
+          </a:lnRef>
+          <a:fillRef idx="1">
+            <a:schemeClr val="accent1"/>
+          </a:fillRef>
+          <a:effectRef idx="0">
+            <a:schemeClr val="accent1"/>
+          </a:effectRef>
+          <a:fontRef idx="minor">
+            <a:schemeClr val="lt1"/>
+          </a:fontRef>
+        </p:style>
+        <p:txBody>
+          <a:bodyPr rtlCol="0" anchor="ctr"/>
+          <a:lstStyle/>
+          <a:p>
+            <a:pPr algn="ctr"/>
+            <a:endParaRPr lang="en-US"/>
+          </a:p>
+        </p:txBody>
+      </p:sp>
+      <mc:AlternateContent xmlns:mc="http://schemas.openxmlformats.org/markup-compatibility/2006">
+        <mc:Choice xmlns:a14="http://schemas.microsoft.com/office/drawing/2010/main" Requires="a14">
+          <p:sp>
+            <p:nvSpPr>
+              <p:cNvPr id="32" name="TextBox 31">
+                <a:extLst>
+                  <a:ext uri="{FF2B5EF4-FFF2-40B4-BE49-F238E27FC236}">
+                    <a16:creationId xmlns:a16="http://schemas.microsoft.com/office/drawing/2014/main" id="{D1BC55CE-5F12-A00C-F1F0-5A6B35E38FB9}"/>
+                  </a:ext>
+                </a:extLst>
+              </p:cNvPr>
+              <p:cNvSpPr txBox="1"/>
+              <p:nvPr/>
+            </p:nvSpPr>
+            <p:spPr>
+              <a:xfrm>
+                <a:off x="1354875" y="2510167"/>
+                <a:ext cx="1371600" cy="646331"/>
+              </a:xfrm>
+              <a:prstGeom prst="rect">
+                <a:avLst/>
+              </a:prstGeom>
+              <a:noFill/>
+            </p:spPr>
+            <p:txBody>
+              <a:bodyPr wrap="square" rtlCol="0">
+                <a:spAutoFit/>
+              </a:bodyPr>
+              <a:lstStyle/>
+              <a:p>
+                <a:r>
+                  <a:rPr lang="en-US" dirty="0"/>
+                  <a:t>Household </a:t>
+                </a:r>
+              </a:p>
+              <a:p>
+                <a:pPr algn="ctr"/>
+                <a14:m>
+                  <m:oMathPara xmlns:m="http://schemas.openxmlformats.org/officeDocument/2006/math">
+                    <m:oMathParaPr>
+                      <m:jc m:val="centerGroup"/>
+                    </m:oMathParaPr>
+                    <m:oMath xmlns:m="http://schemas.openxmlformats.org/officeDocument/2006/math">
+                      <m:r>
+                        <a:rPr lang="en-US" b="0" i="1" smtClean="0">
+                          <a:latin typeface="Cambria Math" panose="02040503050406030204" pitchFamily="18" charset="0"/>
+                        </a:rPr>
+                        <m:t>𝐴</m:t>
+                      </m:r>
+                    </m:oMath>
+                  </m:oMathPara>
+                </a14:m>
+                <a:endParaRPr lang="en-US" dirty="0"/>
+              </a:p>
+            </p:txBody>
+          </p:sp>
+        </mc:Choice>
+        <mc:Fallback>
+          <p:sp>
+            <p:nvSpPr>
+              <p:cNvPr id="32" name="TextBox 31">
+                <a:extLst>
+                  <a:ext uri="{FF2B5EF4-FFF2-40B4-BE49-F238E27FC236}">
+                    <a16:creationId xmlns:a16="http://schemas.microsoft.com/office/drawing/2014/main" id="{D1BC55CE-5F12-A00C-F1F0-5A6B35E38FB9}"/>
+                  </a:ext>
+                </a:extLst>
+              </p:cNvPr>
+              <p:cNvSpPr txBox="1">
+                <a:spLocks noRot="1" noChangeAspect="1" noMove="1" noResize="1" noEditPoints="1" noAdjustHandles="1" noChangeArrowheads="1" noChangeShapeType="1" noTextEdit="1"/>
+              </p:cNvSpPr>
+              <p:nvPr/>
+            </p:nvSpPr>
+            <p:spPr>
+              <a:xfrm>
+                <a:off x="1354875" y="2510167"/>
+                <a:ext cx="1371600" cy="646331"/>
+              </a:xfrm>
+              <a:prstGeom prst="rect">
+                <a:avLst/>
+              </a:prstGeom>
+              <a:blipFill>
+                <a:blip r:embed="rId2"/>
+                <a:stretch>
+                  <a:fillRect l="-3556" t="-4717"/>
+                </a:stretch>
+              </a:blipFill>
+            </p:spPr>
+            <p:txBody>
+              <a:bodyPr/>
+              <a:lstStyle/>
+              <a:p>
+                <a:r>
+                  <a:rPr lang="en-US">
+                    <a:noFill/>
+                  </a:rPr>
+                  <a:t> </a:t>
+                </a:r>
+              </a:p>
+            </p:txBody>
+          </p:sp>
+        </mc:Fallback>
+      </mc:AlternateContent>
+      <mc:AlternateContent xmlns:mc="http://schemas.openxmlformats.org/markup-compatibility/2006">
+        <mc:Choice xmlns:a14="http://schemas.microsoft.com/office/drawing/2010/main" Requires="a14">
+          <p:sp>
+            <p:nvSpPr>
+              <p:cNvPr id="33" name="TextBox 32">
+                <a:extLst>
+                  <a:ext uri="{FF2B5EF4-FFF2-40B4-BE49-F238E27FC236}">
+                    <a16:creationId xmlns:a16="http://schemas.microsoft.com/office/drawing/2014/main" id="{290DEE3F-97D5-0176-F7AD-DA530AC75DB8}"/>
+                  </a:ext>
+                </a:extLst>
+              </p:cNvPr>
+              <p:cNvSpPr txBox="1"/>
+              <p:nvPr/>
+            </p:nvSpPr>
+            <p:spPr>
+              <a:xfrm>
+                <a:off x="3073618" y="2505054"/>
+                <a:ext cx="1371600" cy="646331"/>
+              </a:xfrm>
+              <a:prstGeom prst="rect">
+                <a:avLst/>
+              </a:prstGeom>
+              <a:noFill/>
+            </p:spPr>
+            <p:txBody>
+              <a:bodyPr wrap="square" rtlCol="0">
+                <a:spAutoFit/>
+              </a:bodyPr>
+              <a:lstStyle/>
+              <a:p>
+                <a:r>
+                  <a:rPr lang="en-US" dirty="0"/>
+                  <a:t>Household </a:t>
+                </a:r>
+              </a:p>
+              <a:p>
+                <a:pPr algn="ctr"/>
+                <a14:m>
+                  <m:oMathPara xmlns:m="http://schemas.openxmlformats.org/officeDocument/2006/math">
+                    <m:oMathParaPr>
+                      <m:jc m:val="centerGroup"/>
+                    </m:oMathParaPr>
+                    <m:oMath xmlns:m="http://schemas.openxmlformats.org/officeDocument/2006/math">
+                      <m:r>
+                        <a:rPr lang="en-US" b="0" i="1" smtClean="0">
+                          <a:latin typeface="Cambria Math" panose="02040503050406030204" pitchFamily="18" charset="0"/>
+                        </a:rPr>
+                        <m:t>𝐵</m:t>
+                      </m:r>
+                    </m:oMath>
+                  </m:oMathPara>
+                </a14:m>
+                <a:endParaRPr lang="en-US" dirty="0"/>
+              </a:p>
+            </p:txBody>
+          </p:sp>
+        </mc:Choice>
+        <mc:Fallback>
+          <p:sp>
+            <p:nvSpPr>
+              <p:cNvPr id="33" name="TextBox 32">
+                <a:extLst>
+                  <a:ext uri="{FF2B5EF4-FFF2-40B4-BE49-F238E27FC236}">
+                    <a16:creationId xmlns:a16="http://schemas.microsoft.com/office/drawing/2014/main" id="{290DEE3F-97D5-0176-F7AD-DA530AC75DB8}"/>
+                  </a:ext>
+                </a:extLst>
+              </p:cNvPr>
+              <p:cNvSpPr txBox="1">
+                <a:spLocks noRot="1" noChangeAspect="1" noMove="1" noResize="1" noEditPoints="1" noAdjustHandles="1" noChangeArrowheads="1" noChangeShapeType="1" noTextEdit="1"/>
+              </p:cNvSpPr>
+              <p:nvPr/>
+            </p:nvSpPr>
+            <p:spPr>
+              <a:xfrm>
+                <a:off x="3073618" y="2505054"/>
+                <a:ext cx="1371600" cy="646331"/>
+              </a:xfrm>
+              <a:prstGeom prst="rect">
+                <a:avLst/>
+              </a:prstGeom>
+              <a:blipFill>
+                <a:blip r:embed="rId3"/>
+                <a:stretch>
+                  <a:fillRect l="-3556" t="-4717"/>
+                </a:stretch>
+              </a:blipFill>
+            </p:spPr>
+            <p:txBody>
+              <a:bodyPr/>
+              <a:lstStyle/>
+              <a:p>
+                <a:r>
+                  <a:rPr lang="en-US">
+                    <a:noFill/>
+                  </a:rPr>
+                  <a:t> </a:t>
+                </a:r>
+              </a:p>
+            </p:txBody>
+          </p:sp>
+        </mc:Fallback>
+      </mc:AlternateContent>
+      <p:sp>
+        <p:nvSpPr>
+          <p:cNvPr id="9" name="TextBox 8">
+            <a:extLst>
+              <a:ext uri="{FF2B5EF4-FFF2-40B4-BE49-F238E27FC236}">
+                <a16:creationId xmlns:a16="http://schemas.microsoft.com/office/drawing/2014/main" id="{FF26A319-E0C9-BA37-A07D-9A4AA7E6A493}"/>
+              </a:ext>
+            </a:extLst>
+          </p:cNvPr>
+          <p:cNvSpPr txBox="1"/>
+          <p:nvPr/>
+        </p:nvSpPr>
+        <p:spPr>
+          <a:xfrm>
+            <a:off x="777303" y="123599"/>
+            <a:ext cx="9547852" cy="1661993"/>
+          </a:xfrm>
+          <a:prstGeom prst="rect">
+            <a:avLst/>
+          </a:prstGeom>
+          <a:noFill/>
+        </p:spPr>
+        <p:txBody>
+          <a:bodyPr wrap="square" lIns="0" tIns="0" rIns="0" bIns="0" rtlCol="0">
+            <a:spAutoFit/>
+          </a:bodyPr>
+          <a:lstStyle/>
+          <a:p>
+            <a:r>
+              <a:rPr lang="en-US" sz="3600" dirty="0"/>
+              <a:t>Two hypothetical populations with matching household size and means but different configurations</a:t>
+            </a:r>
+          </a:p>
+        </p:txBody>
+      </p:sp>
+      <p:sp>
+        <p:nvSpPr>
+          <p:cNvPr id="20" name="Oval 19">
+            <a:extLst>
+              <a:ext uri="{FF2B5EF4-FFF2-40B4-BE49-F238E27FC236}">
+                <a16:creationId xmlns:a16="http://schemas.microsoft.com/office/drawing/2014/main" id="{1E152D99-D021-A64E-A43C-823C6CA5CF72}"/>
+              </a:ext>
+            </a:extLst>
+          </p:cNvPr>
+          <p:cNvSpPr/>
+          <p:nvPr/>
+        </p:nvSpPr>
+        <p:spPr>
+          <a:xfrm>
+            <a:off x="2101036" y="3955763"/>
+            <a:ext cx="274320" cy="274320"/>
+          </a:xfrm>
+          <a:prstGeom prst="ellipse">
+            <a:avLst/>
+          </a:prstGeom>
+          <a:noFill/>
+          <a:ln>
+            <a:solidFill>
+              <a:schemeClr val="tx1"/>
+            </a:solidFill>
+          </a:ln>
+        </p:spPr>
+        <p:style>
+          <a:lnRef idx="2">
+            <a:schemeClr val="accent1">
+              <a:shade val="15000"/>
+            </a:schemeClr>
+          </a:lnRef>
+          <a:fillRef idx="1">
+            <a:schemeClr val="accent1"/>
+          </a:fillRef>
+          <a:effectRef idx="0">
+            <a:schemeClr val="accent1"/>
+          </a:effectRef>
+          <a:fontRef idx="minor">
+            <a:schemeClr val="lt1"/>
+          </a:fontRef>
+        </p:style>
+        <p:txBody>
+          <a:bodyPr rtlCol="0" anchor="ctr"/>
+          <a:lstStyle/>
+          <a:p>
+            <a:pPr algn="ctr"/>
+            <a:endParaRPr lang="en-US"/>
+          </a:p>
+        </p:txBody>
+      </p:sp>
+      <p:sp>
+        <p:nvSpPr>
+          <p:cNvPr id="21" name="Oval 20">
+            <a:extLst>
+              <a:ext uri="{FF2B5EF4-FFF2-40B4-BE49-F238E27FC236}">
+                <a16:creationId xmlns:a16="http://schemas.microsoft.com/office/drawing/2014/main" id="{20D6A55D-C90B-B614-D77C-125EA1E8AFF6}"/>
+              </a:ext>
+            </a:extLst>
+          </p:cNvPr>
+          <p:cNvSpPr/>
+          <p:nvPr/>
+        </p:nvSpPr>
+        <p:spPr>
+          <a:xfrm>
+            <a:off x="1894835" y="3557179"/>
+            <a:ext cx="274320" cy="274320"/>
+          </a:xfrm>
+          <a:prstGeom prst="ellipse">
+            <a:avLst/>
+          </a:prstGeom>
+          <a:noFill/>
+          <a:ln>
+            <a:solidFill>
+              <a:schemeClr val="tx1"/>
+            </a:solidFill>
+          </a:ln>
+        </p:spPr>
+        <p:style>
+          <a:lnRef idx="2">
+            <a:schemeClr val="accent1">
+              <a:shade val="15000"/>
+            </a:schemeClr>
+          </a:lnRef>
+          <a:fillRef idx="1">
+            <a:schemeClr val="accent1"/>
+          </a:fillRef>
+          <a:effectRef idx="0">
+            <a:schemeClr val="accent1"/>
+          </a:effectRef>
+          <a:fontRef idx="minor">
+            <a:schemeClr val="lt1"/>
+          </a:fontRef>
+        </p:style>
+        <p:txBody>
+          <a:bodyPr rtlCol="0" anchor="ctr"/>
+          <a:lstStyle/>
+          <a:p>
+            <a:pPr algn="ctr"/>
+            <a:endParaRPr lang="en-US"/>
+          </a:p>
+        </p:txBody>
+      </p:sp>
+      <mc:AlternateContent xmlns:mc="http://schemas.openxmlformats.org/markup-compatibility/2006" xmlns:a14="http://schemas.microsoft.com/office/drawing/2010/main">
+        <mc:Choice Requires="a14">
+          <p:sp>
+            <p:nvSpPr>
+              <p:cNvPr id="25" name="TextBox 24">
+                <a:extLst>
+                  <a:ext uri="{FF2B5EF4-FFF2-40B4-BE49-F238E27FC236}">
+                    <a16:creationId xmlns:a16="http://schemas.microsoft.com/office/drawing/2014/main" id="{6363638B-5A2E-3156-2B8D-D5E186EFF966}"/>
+                  </a:ext>
+                </a:extLst>
+              </p:cNvPr>
+              <p:cNvSpPr txBox="1"/>
+              <p:nvPr/>
+            </p:nvSpPr>
+            <p:spPr>
+              <a:xfrm>
+                <a:off x="6258275" y="6053308"/>
+                <a:ext cx="875881" cy="516745"/>
+              </a:xfrm>
+              <a:prstGeom prst="rect">
+                <a:avLst/>
+              </a:prstGeom>
+              <a:noFill/>
+            </p:spPr>
+            <p:txBody>
+              <a:bodyPr wrap="none" lIns="0" tIns="0" rIns="0" bIns="0" rtlCol="0">
+                <a:spAutoFit/>
+              </a:bodyPr>
+              <a:lstStyle/>
+              <a:p>
+                <a:pPr/>
+                <a14:m>
+                  <m:oMathPara xmlns:m="http://schemas.openxmlformats.org/officeDocument/2006/math">
+                    <m:oMathParaPr>
+                      <m:jc m:val="centerGroup"/>
+                    </m:oMathParaPr>
+                    <m:oMath xmlns:m="http://schemas.openxmlformats.org/officeDocument/2006/math">
+                      <m:sSub>
+                        <m:sSubPr>
+                          <m:ctrlPr>
+                            <a:rPr lang="en-US" b="0" i="1" smtClean="0">
+                              <a:latin typeface="Cambria Math" panose="02040503050406030204" pitchFamily="18" charset="0"/>
+                            </a:rPr>
+                          </m:ctrlPr>
+                        </m:sSubPr>
+                        <m:e>
+                          <m:r>
+                            <a:rPr lang="en-US" b="0" i="1" smtClean="0">
+                              <a:latin typeface="Cambria Math" panose="02040503050406030204" pitchFamily="18" charset="0"/>
+                            </a:rPr>
+                            <m:t>𝑀</m:t>
+                          </m:r>
+                        </m:e>
+                        <m:sub>
+                          <m:r>
+                            <a:rPr lang="en-US" b="0" i="1" smtClean="0">
+                              <a:latin typeface="Cambria Math" panose="02040503050406030204" pitchFamily="18" charset="0"/>
+                            </a:rPr>
+                            <m:t>h</m:t>
+                          </m:r>
+                        </m:sub>
+                      </m:sSub>
+                      <m:r>
+                        <a:rPr lang="en-US" b="0" i="1" smtClean="0">
+                          <a:latin typeface="Cambria Math" panose="02040503050406030204" pitchFamily="18" charset="0"/>
+                        </a:rPr>
+                        <m:t>= </m:t>
+                      </m:r>
+                      <m:f>
+                        <m:fPr>
+                          <m:ctrlPr>
+                            <a:rPr lang="en-US" b="0" i="1" smtClean="0">
+                              <a:latin typeface="Cambria Math" panose="02040503050406030204" pitchFamily="18" charset="0"/>
+                            </a:rPr>
+                          </m:ctrlPr>
+                        </m:fPr>
+                        <m:num>
+                          <m:r>
+                            <a:rPr lang="en-US" b="0" i="1" smtClean="0">
+                              <a:latin typeface="Cambria Math" panose="02040503050406030204" pitchFamily="18" charset="0"/>
+                            </a:rPr>
+                            <m:t>𝑃</m:t>
+                          </m:r>
+                        </m:num>
+                        <m:den>
+                          <m:r>
+                            <a:rPr lang="en-US" b="0" i="1" smtClean="0">
+                              <a:latin typeface="Cambria Math" panose="02040503050406030204" pitchFamily="18" charset="0"/>
+                            </a:rPr>
+                            <m:t>𝐻</m:t>
+                          </m:r>
+                        </m:den>
+                      </m:f>
+                    </m:oMath>
+                  </m:oMathPara>
+                </a14:m>
+                <a:endParaRPr lang="en-US" b="0" dirty="0"/>
+              </a:p>
+            </p:txBody>
+          </p:sp>
+        </mc:Choice>
+        <mc:Fallback xmlns="">
+          <p:sp>
+            <p:nvSpPr>
+              <p:cNvPr id="25" name="TextBox 24">
+                <a:extLst>
+                  <a:ext uri="{FF2B5EF4-FFF2-40B4-BE49-F238E27FC236}">
+                    <a16:creationId xmlns:a16="http://schemas.microsoft.com/office/drawing/2014/main" id="{43F3A35B-B807-D63A-40C8-A4185F79BE12}"/>
+                  </a:ext>
+                </a:extLst>
+              </p:cNvPr>
+              <p:cNvSpPr txBox="1">
+                <a:spLocks noRot="1" noChangeAspect="1" noMove="1" noResize="1" noEditPoints="1" noAdjustHandles="1" noChangeArrowheads="1" noChangeShapeType="1" noTextEdit="1"/>
+              </p:cNvSpPr>
+              <p:nvPr/>
+            </p:nvSpPr>
+            <p:spPr>
+              <a:xfrm>
+                <a:off x="6258275" y="6053308"/>
+                <a:ext cx="875881" cy="516745"/>
+              </a:xfrm>
+              <a:prstGeom prst="rect">
+                <a:avLst/>
+              </a:prstGeom>
+              <a:blipFill>
+                <a:blip r:embed="rId6"/>
+                <a:stretch>
+                  <a:fillRect/>
+                </a:stretch>
+              </a:blipFill>
+            </p:spPr>
+            <p:txBody>
+              <a:bodyPr/>
+              <a:lstStyle/>
+              <a:p>
+                <a:r>
+                  <a:rPr lang="en-US">
+                    <a:noFill/>
+                  </a:rPr>
+                  <a:t> </a:t>
+                </a:r>
+              </a:p>
+            </p:txBody>
+          </p:sp>
+        </mc:Fallback>
+      </mc:AlternateContent>
+      <p:sp>
+        <p:nvSpPr>
+          <p:cNvPr id="36" name="Oval 35">
+            <a:extLst>
+              <a:ext uri="{FF2B5EF4-FFF2-40B4-BE49-F238E27FC236}">
+                <a16:creationId xmlns:a16="http://schemas.microsoft.com/office/drawing/2014/main" id="{7215D237-A880-B77C-EBA0-B64500A88986}"/>
+              </a:ext>
+            </a:extLst>
+          </p:cNvPr>
+          <p:cNvSpPr/>
+          <p:nvPr/>
+        </p:nvSpPr>
+        <p:spPr>
+          <a:xfrm>
+            <a:off x="1673466" y="3956322"/>
+            <a:ext cx="274320" cy="274320"/>
+          </a:xfrm>
+          <a:prstGeom prst="ellipse">
+            <a:avLst/>
+          </a:prstGeom>
+          <a:noFill/>
+          <a:ln>
+            <a:solidFill>
+              <a:schemeClr val="tx1"/>
+            </a:solidFill>
+          </a:ln>
+        </p:spPr>
+        <p:style>
+          <a:lnRef idx="2">
+            <a:schemeClr val="accent1">
+              <a:shade val="15000"/>
+            </a:schemeClr>
+          </a:lnRef>
+          <a:fillRef idx="1">
+            <a:schemeClr val="accent1"/>
+          </a:fillRef>
+          <a:effectRef idx="0">
+            <a:schemeClr val="accent1"/>
+          </a:effectRef>
+          <a:fontRef idx="minor">
+            <a:schemeClr val="lt1"/>
+          </a:fontRef>
+        </p:style>
+        <p:txBody>
+          <a:bodyPr rtlCol="0" anchor="ctr"/>
+          <a:lstStyle/>
+          <a:p>
+            <a:pPr algn="ctr"/>
+            <a:endParaRPr lang="en-US"/>
+          </a:p>
+        </p:txBody>
+      </p:sp>
+      <p:sp>
+        <p:nvSpPr>
+          <p:cNvPr id="43" name="Rectangle 42">
+            <a:extLst>
+              <a:ext uri="{FF2B5EF4-FFF2-40B4-BE49-F238E27FC236}">
+                <a16:creationId xmlns:a16="http://schemas.microsoft.com/office/drawing/2014/main" id="{BC96C22B-3837-19C7-35A0-0C9501B55A90}"/>
+              </a:ext>
+            </a:extLst>
+          </p:cNvPr>
+          <p:cNvSpPr/>
+          <p:nvPr/>
+        </p:nvSpPr>
+        <p:spPr>
+          <a:xfrm>
+            <a:off x="1346195" y="3197219"/>
+            <a:ext cx="1371600" cy="1411550"/>
+          </a:xfrm>
+          <a:prstGeom prst="rect">
+            <a:avLst/>
+          </a:prstGeom>
+          <a:noFill/>
+          <a:ln>
+            <a:solidFill>
+              <a:schemeClr val="tx1"/>
+            </a:solidFill>
+          </a:ln>
+        </p:spPr>
+        <p:style>
+          <a:lnRef idx="2">
+            <a:schemeClr val="accent1">
+              <a:shade val="15000"/>
+            </a:schemeClr>
+          </a:lnRef>
+          <a:fillRef idx="1">
+            <a:schemeClr val="accent1"/>
+          </a:fillRef>
+          <a:effectRef idx="0">
+            <a:schemeClr val="accent1"/>
+          </a:effectRef>
+          <a:fontRef idx="minor">
+            <a:schemeClr val="lt1"/>
+          </a:fontRef>
+        </p:style>
+        <p:txBody>
+          <a:bodyPr rtlCol="0" anchor="ctr"/>
+          <a:lstStyle/>
+          <a:p>
+            <a:pPr algn="ctr"/>
+            <a:endParaRPr lang="en-US"/>
+          </a:p>
+        </p:txBody>
+      </p:sp>
+      <p:sp>
+        <p:nvSpPr>
+          <p:cNvPr id="49" name="Rectangle 48">
+            <a:extLst>
+              <a:ext uri="{FF2B5EF4-FFF2-40B4-BE49-F238E27FC236}">
+                <a16:creationId xmlns:a16="http://schemas.microsoft.com/office/drawing/2014/main" id="{FF8D0B59-37C0-4C96-D20D-2D6EF9B932CF}"/>
+              </a:ext>
+            </a:extLst>
+          </p:cNvPr>
+          <p:cNvSpPr/>
+          <p:nvPr/>
+        </p:nvSpPr>
+        <p:spPr>
+          <a:xfrm>
+            <a:off x="6212479" y="3268714"/>
+            <a:ext cx="1371600" cy="1411550"/>
+          </a:xfrm>
+          <a:prstGeom prst="rect">
+            <a:avLst/>
+          </a:prstGeom>
+          <a:noFill/>
+          <a:ln>
+            <a:noFill/>
+          </a:ln>
+        </p:spPr>
+        <p:style>
+          <a:lnRef idx="2">
+            <a:schemeClr val="accent1">
+              <a:shade val="15000"/>
+            </a:schemeClr>
+          </a:lnRef>
+          <a:fillRef idx="1">
+            <a:schemeClr val="accent1"/>
+          </a:fillRef>
+          <a:effectRef idx="0">
+            <a:schemeClr val="accent1"/>
+          </a:effectRef>
+          <a:fontRef idx="minor">
+            <a:schemeClr val="lt1"/>
+          </a:fontRef>
+        </p:style>
+        <p:txBody>
+          <a:bodyPr rtlCol="0" anchor="ctr"/>
+          <a:lstStyle/>
+          <a:p>
+            <a:pPr algn="ctr"/>
+            <a:endParaRPr lang="en-US"/>
+          </a:p>
+        </p:txBody>
+      </p:sp>
+      <mc:AlternateContent xmlns:mc="http://schemas.openxmlformats.org/markup-compatibility/2006">
+        <mc:Choice xmlns:a14="http://schemas.microsoft.com/office/drawing/2010/main" Requires="a14">
+          <p:sp>
+            <p:nvSpPr>
+              <p:cNvPr id="3" name="TextBox 2">
+                <a:extLst>
+                  <a:ext uri="{FF2B5EF4-FFF2-40B4-BE49-F238E27FC236}">
+                    <a16:creationId xmlns:a16="http://schemas.microsoft.com/office/drawing/2014/main" id="{6310690B-6A2F-BA63-A164-1A68BE8C091A}"/>
+                  </a:ext>
+                </a:extLst>
+              </p:cNvPr>
+              <p:cNvSpPr txBox="1"/>
+              <p:nvPr/>
+            </p:nvSpPr>
+            <p:spPr>
+              <a:xfrm>
+                <a:off x="6001724" y="2516940"/>
+                <a:ext cx="1371600" cy="646331"/>
+              </a:xfrm>
+              <a:prstGeom prst="rect">
+                <a:avLst/>
+              </a:prstGeom>
+              <a:noFill/>
+            </p:spPr>
+            <p:txBody>
+              <a:bodyPr wrap="square" rtlCol="0">
+                <a:spAutoFit/>
+              </a:bodyPr>
+              <a:lstStyle/>
+              <a:p>
+                <a:r>
+                  <a:rPr lang="en-US" dirty="0"/>
+                  <a:t>Household </a:t>
+                </a:r>
+              </a:p>
+              <a:p>
+                <a:pPr algn="ctr"/>
+                <a14:m>
+                  <m:oMathPara xmlns:m="http://schemas.openxmlformats.org/officeDocument/2006/math">
+                    <m:oMathParaPr>
+                      <m:jc m:val="centerGroup"/>
+                    </m:oMathParaPr>
+                    <m:oMath xmlns:m="http://schemas.openxmlformats.org/officeDocument/2006/math">
+                      <m:r>
+                        <a:rPr lang="en-US" b="0" i="1" smtClean="0">
+                          <a:latin typeface="Cambria Math" panose="02040503050406030204" pitchFamily="18" charset="0"/>
+                        </a:rPr>
+                        <m:t>𝐴</m:t>
+                      </m:r>
+                    </m:oMath>
+                  </m:oMathPara>
+                </a14:m>
+                <a:endParaRPr lang="en-US" dirty="0"/>
+              </a:p>
+            </p:txBody>
+          </p:sp>
+        </mc:Choice>
+        <mc:Fallback>
+          <p:sp>
+            <p:nvSpPr>
+              <p:cNvPr id="3" name="TextBox 2">
+                <a:extLst>
+                  <a:ext uri="{FF2B5EF4-FFF2-40B4-BE49-F238E27FC236}">
+                    <a16:creationId xmlns:a16="http://schemas.microsoft.com/office/drawing/2014/main" id="{6310690B-6A2F-BA63-A164-1A68BE8C091A}"/>
+                  </a:ext>
+                </a:extLst>
+              </p:cNvPr>
+              <p:cNvSpPr txBox="1">
+                <a:spLocks noRot="1" noChangeAspect="1" noMove="1" noResize="1" noEditPoints="1" noAdjustHandles="1" noChangeArrowheads="1" noChangeShapeType="1" noTextEdit="1"/>
+              </p:cNvSpPr>
+              <p:nvPr/>
+            </p:nvSpPr>
+            <p:spPr>
+              <a:xfrm>
+                <a:off x="6001724" y="2516940"/>
+                <a:ext cx="1371600" cy="646331"/>
+              </a:xfrm>
+              <a:prstGeom prst="rect">
+                <a:avLst/>
+              </a:prstGeom>
+              <a:blipFill>
+                <a:blip r:embed="rId7"/>
+                <a:stretch>
+                  <a:fillRect l="-4000" t="-4717"/>
+                </a:stretch>
+              </a:blipFill>
+            </p:spPr>
+            <p:txBody>
+              <a:bodyPr/>
+              <a:lstStyle/>
+              <a:p>
+                <a:r>
+                  <a:rPr lang="en-US">
+                    <a:noFill/>
+                  </a:rPr>
+                  <a:t> </a:t>
+                </a:r>
+              </a:p>
+            </p:txBody>
+          </p:sp>
+        </mc:Fallback>
+      </mc:AlternateContent>
+      <mc:AlternateContent xmlns:mc="http://schemas.openxmlformats.org/markup-compatibility/2006">
+        <mc:Choice xmlns:a14="http://schemas.microsoft.com/office/drawing/2010/main" Requires="a14">
+          <p:sp>
+            <p:nvSpPr>
+              <p:cNvPr id="5" name="TextBox 4">
+                <a:extLst>
+                  <a:ext uri="{FF2B5EF4-FFF2-40B4-BE49-F238E27FC236}">
+                    <a16:creationId xmlns:a16="http://schemas.microsoft.com/office/drawing/2014/main" id="{AB27C541-014F-4268-FAD3-7953CBB0BC2B}"/>
+                  </a:ext>
+                </a:extLst>
+              </p:cNvPr>
+              <p:cNvSpPr txBox="1"/>
+              <p:nvPr/>
+            </p:nvSpPr>
+            <p:spPr>
+              <a:xfrm>
+                <a:off x="7720467" y="2505054"/>
+                <a:ext cx="1371600" cy="646331"/>
+              </a:xfrm>
+              <a:prstGeom prst="rect">
+                <a:avLst/>
+              </a:prstGeom>
+              <a:noFill/>
+            </p:spPr>
+            <p:txBody>
+              <a:bodyPr wrap="square" rtlCol="0">
+                <a:spAutoFit/>
+              </a:bodyPr>
+              <a:lstStyle/>
+              <a:p>
+                <a:r>
+                  <a:rPr lang="en-US" dirty="0"/>
+                  <a:t>Household </a:t>
+                </a:r>
+              </a:p>
+              <a:p>
+                <a:pPr algn="ctr"/>
+                <a14:m>
+                  <m:oMathPara xmlns:m="http://schemas.openxmlformats.org/officeDocument/2006/math">
+                    <m:oMathParaPr>
+                      <m:jc m:val="centerGroup"/>
+                    </m:oMathParaPr>
+                    <m:oMath xmlns:m="http://schemas.openxmlformats.org/officeDocument/2006/math">
+                      <m:r>
+                        <a:rPr lang="en-US" b="0" i="1" smtClean="0">
+                          <a:latin typeface="Cambria Math" panose="02040503050406030204" pitchFamily="18" charset="0"/>
+                        </a:rPr>
+                        <m:t>𝐵</m:t>
+                      </m:r>
+                    </m:oMath>
+                  </m:oMathPara>
+                </a14:m>
+                <a:endParaRPr lang="en-US" dirty="0"/>
+              </a:p>
+            </p:txBody>
+          </p:sp>
+        </mc:Choice>
+        <mc:Fallback>
+          <p:sp>
+            <p:nvSpPr>
+              <p:cNvPr id="5" name="TextBox 4">
+                <a:extLst>
+                  <a:ext uri="{FF2B5EF4-FFF2-40B4-BE49-F238E27FC236}">
+                    <a16:creationId xmlns:a16="http://schemas.microsoft.com/office/drawing/2014/main" id="{AB27C541-014F-4268-FAD3-7953CBB0BC2B}"/>
+                  </a:ext>
+                </a:extLst>
+              </p:cNvPr>
+              <p:cNvSpPr txBox="1">
+                <a:spLocks noRot="1" noChangeAspect="1" noMove="1" noResize="1" noEditPoints="1" noAdjustHandles="1" noChangeArrowheads="1" noChangeShapeType="1" noTextEdit="1"/>
+              </p:cNvSpPr>
+              <p:nvPr/>
+            </p:nvSpPr>
+            <p:spPr>
+              <a:xfrm>
+                <a:off x="7720467" y="2505054"/>
+                <a:ext cx="1371600" cy="646331"/>
+              </a:xfrm>
+              <a:prstGeom prst="rect">
+                <a:avLst/>
+              </a:prstGeom>
+              <a:blipFill>
+                <a:blip r:embed="rId8"/>
+                <a:stretch>
+                  <a:fillRect l="-3556" t="-4717"/>
+                </a:stretch>
+              </a:blipFill>
+            </p:spPr>
+            <p:txBody>
+              <a:bodyPr/>
+              <a:lstStyle/>
+              <a:p>
+                <a:r>
+                  <a:rPr lang="en-US">
+                    <a:noFill/>
+                  </a:rPr>
+                  <a:t> </a:t>
+                </a:r>
+              </a:p>
+            </p:txBody>
+          </p:sp>
+        </mc:Fallback>
+      </mc:AlternateContent>
+      <p:sp>
+        <p:nvSpPr>
+          <p:cNvPr id="7" name="Oval 6">
+            <a:extLst>
+              <a:ext uri="{FF2B5EF4-FFF2-40B4-BE49-F238E27FC236}">
+                <a16:creationId xmlns:a16="http://schemas.microsoft.com/office/drawing/2014/main" id="{318B50A5-6C05-077C-FB9F-5E06874CF64B}"/>
+              </a:ext>
+            </a:extLst>
+          </p:cNvPr>
+          <p:cNvSpPr/>
+          <p:nvPr/>
+        </p:nvSpPr>
+        <p:spPr>
+          <a:xfrm>
+            <a:off x="8286720" y="3765834"/>
+            <a:ext cx="274320" cy="274320"/>
+          </a:xfrm>
+          <a:prstGeom prst="ellipse">
+            <a:avLst/>
+          </a:prstGeom>
+          <a:noFill/>
+          <a:ln>
+            <a:solidFill>
+              <a:schemeClr val="tx1"/>
+            </a:solidFill>
+          </a:ln>
+        </p:spPr>
+        <p:style>
+          <a:lnRef idx="2">
+            <a:schemeClr val="accent1">
+              <a:shade val="15000"/>
+            </a:schemeClr>
+          </a:lnRef>
+          <a:fillRef idx="1">
+            <a:schemeClr val="accent1"/>
+          </a:fillRef>
+          <a:effectRef idx="0">
+            <a:schemeClr val="accent1"/>
+          </a:effectRef>
+          <a:fontRef idx="minor">
+            <a:schemeClr val="lt1"/>
+          </a:fontRef>
+        </p:style>
+        <p:txBody>
+          <a:bodyPr rtlCol="0" anchor="ctr"/>
+          <a:lstStyle/>
+          <a:p>
+            <a:pPr algn="ctr"/>
+            <a:endParaRPr lang="en-US"/>
+          </a:p>
+        </p:txBody>
+      </p:sp>
+      <p:sp>
+        <p:nvSpPr>
+          <p:cNvPr id="8" name="Rectangle 7">
+            <a:extLst>
+              <a:ext uri="{FF2B5EF4-FFF2-40B4-BE49-F238E27FC236}">
+                <a16:creationId xmlns:a16="http://schemas.microsoft.com/office/drawing/2014/main" id="{1AF74910-1BDC-4069-D0F3-C55078D0B41E}"/>
+              </a:ext>
+            </a:extLst>
+          </p:cNvPr>
+          <p:cNvSpPr/>
+          <p:nvPr/>
+        </p:nvSpPr>
+        <p:spPr>
+          <a:xfrm>
+            <a:off x="7738080" y="3197219"/>
+            <a:ext cx="1371600" cy="1411550"/>
+          </a:xfrm>
+          <a:prstGeom prst="rect">
+            <a:avLst/>
+          </a:prstGeom>
+          <a:noFill/>
+          <a:ln>
+            <a:solidFill>
+              <a:schemeClr val="tx1"/>
+            </a:solidFill>
+          </a:ln>
+        </p:spPr>
+        <p:style>
+          <a:lnRef idx="2">
+            <a:schemeClr val="accent1">
+              <a:shade val="15000"/>
+            </a:schemeClr>
+          </a:lnRef>
+          <a:fillRef idx="1">
+            <a:schemeClr val="accent1"/>
+          </a:fillRef>
+          <a:effectRef idx="0">
+            <a:schemeClr val="accent1"/>
+          </a:effectRef>
+          <a:fontRef idx="minor">
+            <a:schemeClr val="lt1"/>
+          </a:fontRef>
+        </p:style>
+        <p:txBody>
+          <a:bodyPr rtlCol="0" anchor="ctr"/>
+          <a:lstStyle/>
+          <a:p>
+            <a:pPr algn="ctr"/>
+            <a:endParaRPr lang="en-US"/>
+          </a:p>
+        </p:txBody>
+      </p:sp>
+      <mc:AlternateContent xmlns:mc="http://schemas.openxmlformats.org/markup-compatibility/2006">
+        <mc:Choice xmlns:a14="http://schemas.microsoft.com/office/drawing/2010/main" Requires="a14">
+          <p:sp>
+            <p:nvSpPr>
+              <p:cNvPr id="18" name="TextBox 17">
+                <a:extLst>
+                  <a:ext uri="{FF2B5EF4-FFF2-40B4-BE49-F238E27FC236}">
+                    <a16:creationId xmlns:a16="http://schemas.microsoft.com/office/drawing/2014/main" id="{E000943D-400B-2050-C7B3-59C5FF62B2D9}"/>
+                  </a:ext>
+                </a:extLst>
+              </p:cNvPr>
+              <p:cNvSpPr txBox="1"/>
+              <p:nvPr/>
+            </p:nvSpPr>
+            <p:spPr>
+              <a:xfrm>
+                <a:off x="9447890" y="2505054"/>
+                <a:ext cx="1371600" cy="646331"/>
+              </a:xfrm>
+              <a:prstGeom prst="rect">
+                <a:avLst/>
+              </a:prstGeom>
+              <a:noFill/>
+            </p:spPr>
+            <p:txBody>
+              <a:bodyPr wrap="square" rtlCol="0">
+                <a:spAutoFit/>
+              </a:bodyPr>
+              <a:lstStyle/>
+              <a:p>
+                <a:r>
+                  <a:rPr lang="en-US" dirty="0"/>
+                  <a:t>Household </a:t>
+                </a:r>
+              </a:p>
+              <a:p>
+                <a:pPr algn="ctr"/>
+                <a14:m>
+                  <m:oMathPara xmlns:m="http://schemas.openxmlformats.org/officeDocument/2006/math">
+                    <m:oMathParaPr>
+                      <m:jc m:val="centerGroup"/>
+                    </m:oMathParaPr>
+                    <m:oMath xmlns:m="http://schemas.openxmlformats.org/officeDocument/2006/math">
+                      <m:r>
+                        <a:rPr lang="en-US" b="0" i="1" smtClean="0">
+                          <a:latin typeface="Cambria Math" panose="02040503050406030204" pitchFamily="18" charset="0"/>
+                        </a:rPr>
+                        <m:t>𝐶</m:t>
+                      </m:r>
+                    </m:oMath>
+                  </m:oMathPara>
+                </a14:m>
+                <a:endParaRPr lang="en-US" dirty="0"/>
+              </a:p>
+            </p:txBody>
+          </p:sp>
+        </mc:Choice>
+        <mc:Fallback>
+          <p:sp>
+            <p:nvSpPr>
+              <p:cNvPr id="18" name="TextBox 17">
+                <a:extLst>
+                  <a:ext uri="{FF2B5EF4-FFF2-40B4-BE49-F238E27FC236}">
+                    <a16:creationId xmlns:a16="http://schemas.microsoft.com/office/drawing/2014/main" id="{E000943D-400B-2050-C7B3-59C5FF62B2D9}"/>
+                  </a:ext>
+                </a:extLst>
+              </p:cNvPr>
+              <p:cNvSpPr txBox="1">
+                <a:spLocks noRot="1" noChangeAspect="1" noMove="1" noResize="1" noEditPoints="1" noAdjustHandles="1" noChangeArrowheads="1" noChangeShapeType="1" noTextEdit="1"/>
+              </p:cNvSpPr>
+              <p:nvPr/>
+            </p:nvSpPr>
+            <p:spPr>
+              <a:xfrm>
+                <a:off x="9447890" y="2505054"/>
+                <a:ext cx="1371600" cy="646331"/>
+              </a:xfrm>
+              <a:prstGeom prst="rect">
+                <a:avLst/>
+              </a:prstGeom>
+              <a:blipFill>
+                <a:blip r:embed="rId9"/>
+                <a:stretch>
+                  <a:fillRect l="-4000" t="-4717"/>
+                </a:stretch>
+              </a:blipFill>
+            </p:spPr>
+            <p:txBody>
+              <a:bodyPr/>
+              <a:lstStyle/>
+              <a:p>
+                <a:r>
+                  <a:rPr lang="en-US">
+                    <a:noFill/>
+                  </a:rPr>
+                  <a:t> </a:t>
+                </a:r>
+              </a:p>
+            </p:txBody>
+          </p:sp>
+        </mc:Fallback>
+      </mc:AlternateContent>
+      <p:sp>
+        <p:nvSpPr>
+          <p:cNvPr id="22" name="Oval 21">
+            <a:extLst>
+              <a:ext uri="{FF2B5EF4-FFF2-40B4-BE49-F238E27FC236}">
+                <a16:creationId xmlns:a16="http://schemas.microsoft.com/office/drawing/2014/main" id="{6BCC5F1A-6D0B-64FC-FFBC-1AAE1B7FC66F}"/>
+              </a:ext>
+            </a:extLst>
+          </p:cNvPr>
+          <p:cNvSpPr/>
+          <p:nvPr/>
+        </p:nvSpPr>
+        <p:spPr>
+          <a:xfrm>
+            <a:off x="10014143" y="3765834"/>
+            <a:ext cx="274320" cy="274320"/>
+          </a:xfrm>
+          <a:prstGeom prst="ellipse">
+            <a:avLst/>
+          </a:prstGeom>
+          <a:noFill/>
+          <a:ln>
+            <a:solidFill>
+              <a:schemeClr val="tx1"/>
+            </a:solidFill>
+          </a:ln>
+        </p:spPr>
+        <p:style>
+          <a:lnRef idx="2">
+            <a:schemeClr val="accent1">
+              <a:shade val="15000"/>
+            </a:schemeClr>
+          </a:lnRef>
+          <a:fillRef idx="1">
+            <a:schemeClr val="accent1"/>
+          </a:fillRef>
+          <a:effectRef idx="0">
+            <a:schemeClr val="accent1"/>
+          </a:effectRef>
+          <a:fontRef idx="minor">
+            <a:schemeClr val="lt1"/>
+          </a:fontRef>
+        </p:style>
+        <p:txBody>
+          <a:bodyPr rtlCol="0" anchor="ctr"/>
+          <a:lstStyle/>
+          <a:p>
+            <a:pPr algn="ctr"/>
+            <a:endParaRPr lang="en-US"/>
+          </a:p>
+        </p:txBody>
+      </p:sp>
+      <p:sp>
+        <p:nvSpPr>
+          <p:cNvPr id="23" name="Rectangle 22">
+            <a:extLst>
+              <a:ext uri="{FF2B5EF4-FFF2-40B4-BE49-F238E27FC236}">
+                <a16:creationId xmlns:a16="http://schemas.microsoft.com/office/drawing/2014/main" id="{2ED5319A-1E20-1A58-2622-E5C5CE33A83E}"/>
+              </a:ext>
+            </a:extLst>
+          </p:cNvPr>
+          <p:cNvSpPr/>
+          <p:nvPr/>
+        </p:nvSpPr>
+        <p:spPr>
+          <a:xfrm>
+            <a:off x="9465503" y="3197219"/>
+            <a:ext cx="1371600" cy="1411550"/>
+          </a:xfrm>
+          <a:prstGeom prst="rect">
+            <a:avLst/>
+          </a:prstGeom>
+          <a:noFill/>
+          <a:ln>
+            <a:solidFill>
+              <a:schemeClr val="tx1"/>
+            </a:solidFill>
+          </a:ln>
+        </p:spPr>
+        <p:style>
+          <a:lnRef idx="2">
+            <a:schemeClr val="accent1">
+              <a:shade val="15000"/>
+            </a:schemeClr>
+          </a:lnRef>
+          <a:fillRef idx="1">
+            <a:schemeClr val="accent1"/>
+          </a:fillRef>
+          <a:effectRef idx="0">
+            <a:schemeClr val="accent1"/>
+          </a:effectRef>
+          <a:fontRef idx="minor">
+            <a:schemeClr val="lt1"/>
+          </a:fontRef>
+        </p:style>
+        <p:txBody>
+          <a:bodyPr rtlCol="0" anchor="ctr"/>
+          <a:lstStyle/>
+          <a:p>
+            <a:pPr algn="ctr"/>
+            <a:endParaRPr lang="en-US"/>
+          </a:p>
+        </p:txBody>
+      </p:sp>
+      <p:sp>
+        <p:nvSpPr>
+          <p:cNvPr id="27" name="Rectangle 26">
+            <a:extLst>
+              <a:ext uri="{FF2B5EF4-FFF2-40B4-BE49-F238E27FC236}">
+                <a16:creationId xmlns:a16="http://schemas.microsoft.com/office/drawing/2014/main" id="{A2833940-2677-4C05-1603-829B99E20EC9}"/>
+              </a:ext>
+            </a:extLst>
+          </p:cNvPr>
+          <p:cNvSpPr/>
+          <p:nvPr/>
+        </p:nvSpPr>
+        <p:spPr>
+          <a:xfrm>
+            <a:off x="3045066" y="3197219"/>
+            <a:ext cx="1371600" cy="1411550"/>
+          </a:xfrm>
+          <a:prstGeom prst="rect">
+            <a:avLst/>
+          </a:prstGeom>
+          <a:noFill/>
+          <a:ln>
+            <a:solidFill>
+              <a:schemeClr val="tx1"/>
+            </a:solidFill>
+          </a:ln>
+        </p:spPr>
+        <p:style>
+          <a:lnRef idx="2">
+            <a:schemeClr val="accent1">
+              <a:shade val="15000"/>
+            </a:schemeClr>
+          </a:lnRef>
+          <a:fillRef idx="1">
+            <a:schemeClr val="accent1"/>
+          </a:fillRef>
+          <a:effectRef idx="0">
+            <a:schemeClr val="accent1"/>
+          </a:effectRef>
+          <a:fontRef idx="minor">
+            <a:schemeClr val="lt1"/>
+          </a:fontRef>
+        </p:style>
+        <p:txBody>
+          <a:bodyPr rtlCol="0" anchor="ctr"/>
+          <a:lstStyle/>
+          <a:p>
+            <a:pPr algn="ctr"/>
+            <a:endParaRPr lang="en-US"/>
+          </a:p>
+        </p:txBody>
+      </p:sp>
+      <p:sp>
+        <p:nvSpPr>
+          <p:cNvPr id="28" name="Oval 27">
+            <a:extLst>
+              <a:ext uri="{FF2B5EF4-FFF2-40B4-BE49-F238E27FC236}">
+                <a16:creationId xmlns:a16="http://schemas.microsoft.com/office/drawing/2014/main" id="{7FA43D1A-4E25-3896-3A91-F19A2FC80F88}"/>
+              </a:ext>
+            </a:extLst>
+          </p:cNvPr>
+          <p:cNvSpPr/>
+          <p:nvPr/>
+        </p:nvSpPr>
+        <p:spPr>
+          <a:xfrm>
+            <a:off x="3799907" y="3955763"/>
+            <a:ext cx="274320" cy="274320"/>
+          </a:xfrm>
+          <a:prstGeom prst="ellipse">
+            <a:avLst/>
+          </a:prstGeom>
+          <a:noFill/>
+          <a:ln>
+            <a:solidFill>
+              <a:schemeClr val="tx1"/>
+            </a:solidFill>
+          </a:ln>
+        </p:spPr>
+        <p:style>
+          <a:lnRef idx="2">
+            <a:schemeClr val="accent1">
+              <a:shade val="15000"/>
+            </a:schemeClr>
+          </a:lnRef>
+          <a:fillRef idx="1">
+            <a:schemeClr val="accent1"/>
+          </a:fillRef>
+          <a:effectRef idx="0">
+            <a:schemeClr val="accent1"/>
+          </a:effectRef>
+          <a:fontRef idx="minor">
+            <a:schemeClr val="lt1"/>
+          </a:fontRef>
+        </p:style>
+        <p:txBody>
+          <a:bodyPr rtlCol="0" anchor="ctr"/>
+          <a:lstStyle/>
+          <a:p>
+            <a:pPr algn="ctr"/>
+            <a:endParaRPr lang="en-US"/>
+          </a:p>
+        </p:txBody>
+      </p:sp>
+      <p:sp>
+        <p:nvSpPr>
+          <p:cNvPr id="29" name="Oval 28">
+            <a:extLst>
+              <a:ext uri="{FF2B5EF4-FFF2-40B4-BE49-F238E27FC236}">
+                <a16:creationId xmlns:a16="http://schemas.microsoft.com/office/drawing/2014/main" id="{0D056B4A-1BDC-40B6-9EB9-158C65863CAB}"/>
+              </a:ext>
+            </a:extLst>
+          </p:cNvPr>
+          <p:cNvSpPr/>
+          <p:nvPr/>
+        </p:nvSpPr>
+        <p:spPr>
+          <a:xfrm>
+            <a:off x="3593706" y="3557179"/>
+            <a:ext cx="274320" cy="274320"/>
+          </a:xfrm>
+          <a:prstGeom prst="ellipse">
+            <a:avLst/>
+          </a:prstGeom>
+          <a:noFill/>
+          <a:ln>
+            <a:solidFill>
+              <a:schemeClr val="tx1"/>
+            </a:solidFill>
+          </a:ln>
+        </p:spPr>
+        <p:style>
+          <a:lnRef idx="2">
+            <a:schemeClr val="accent1">
+              <a:shade val="15000"/>
+            </a:schemeClr>
+          </a:lnRef>
+          <a:fillRef idx="1">
+            <a:schemeClr val="accent1"/>
+          </a:fillRef>
+          <a:effectRef idx="0">
+            <a:schemeClr val="accent1"/>
+          </a:effectRef>
+          <a:fontRef idx="minor">
+            <a:schemeClr val="lt1"/>
+          </a:fontRef>
+        </p:style>
+        <p:txBody>
+          <a:bodyPr rtlCol="0" anchor="ctr"/>
+          <a:lstStyle/>
+          <a:p>
+            <a:pPr algn="ctr"/>
+            <a:endParaRPr lang="en-US"/>
+          </a:p>
+        </p:txBody>
+      </p:sp>
+      <p:sp>
+        <p:nvSpPr>
+          <p:cNvPr id="30" name="Oval 29">
+            <a:extLst>
+              <a:ext uri="{FF2B5EF4-FFF2-40B4-BE49-F238E27FC236}">
+                <a16:creationId xmlns:a16="http://schemas.microsoft.com/office/drawing/2014/main" id="{17744F53-54A2-B96C-ED92-A93C654D8099}"/>
+              </a:ext>
+            </a:extLst>
+          </p:cNvPr>
+          <p:cNvSpPr/>
+          <p:nvPr/>
+        </p:nvSpPr>
+        <p:spPr>
+          <a:xfrm>
+            <a:off x="3372337" y="3956322"/>
+            <a:ext cx="274320" cy="274320"/>
+          </a:xfrm>
+          <a:prstGeom prst="ellipse">
+            <a:avLst/>
+          </a:prstGeom>
+          <a:noFill/>
+          <a:ln>
+            <a:solidFill>
+              <a:schemeClr val="tx1"/>
+            </a:solidFill>
+          </a:ln>
+        </p:spPr>
+        <p:style>
+          <a:lnRef idx="2">
+            <a:schemeClr val="accent1">
+              <a:shade val="15000"/>
+            </a:schemeClr>
+          </a:lnRef>
+          <a:fillRef idx="1">
+            <a:schemeClr val="accent1"/>
+          </a:fillRef>
+          <a:effectRef idx="0">
+            <a:schemeClr val="accent1"/>
+          </a:effectRef>
+          <a:fontRef idx="minor">
+            <a:schemeClr val="lt1"/>
+          </a:fontRef>
+        </p:style>
+        <p:txBody>
+          <a:bodyPr rtlCol="0" anchor="ctr"/>
+          <a:lstStyle/>
+          <a:p>
+            <a:pPr algn="ctr"/>
+            <a:endParaRPr lang="en-US"/>
+          </a:p>
+        </p:txBody>
+      </p:sp>
+      <p:sp>
+        <p:nvSpPr>
+          <p:cNvPr id="31" name="Rectangle 30">
+            <a:extLst>
+              <a:ext uri="{FF2B5EF4-FFF2-40B4-BE49-F238E27FC236}">
+                <a16:creationId xmlns:a16="http://schemas.microsoft.com/office/drawing/2014/main" id="{E1F4A4B2-BC7C-D643-8A3E-E400CFB1F4E5}"/>
+              </a:ext>
+            </a:extLst>
+          </p:cNvPr>
+          <p:cNvSpPr/>
+          <p:nvPr/>
+        </p:nvSpPr>
+        <p:spPr>
+          <a:xfrm>
+            <a:off x="3045066" y="3197219"/>
+            <a:ext cx="1371600" cy="1411550"/>
+          </a:xfrm>
+          <a:prstGeom prst="rect">
+            <a:avLst/>
+          </a:prstGeom>
+          <a:noFill/>
+          <a:ln>
+            <a:solidFill>
+              <a:schemeClr val="tx1"/>
+            </a:solidFill>
+          </a:ln>
+        </p:spPr>
+        <p:style>
+          <a:lnRef idx="2">
+            <a:schemeClr val="accent1">
+              <a:shade val="15000"/>
+            </a:schemeClr>
+          </a:lnRef>
+          <a:fillRef idx="1">
+            <a:schemeClr val="accent1"/>
+          </a:fillRef>
+          <a:effectRef idx="0">
+            <a:schemeClr val="accent1"/>
+          </a:effectRef>
+          <a:fontRef idx="minor">
+            <a:schemeClr val="lt1"/>
+          </a:fontRef>
+        </p:style>
+        <p:txBody>
+          <a:bodyPr rtlCol="0" anchor="ctr"/>
+          <a:lstStyle/>
+          <a:p>
+            <a:pPr algn="ctr"/>
+            <a:endParaRPr lang="en-US"/>
+          </a:p>
+        </p:txBody>
+      </p:sp>
+      <p:sp>
+        <p:nvSpPr>
+          <p:cNvPr id="35" name="Rectangle 34">
+            <a:extLst>
+              <a:ext uri="{FF2B5EF4-FFF2-40B4-BE49-F238E27FC236}">
+                <a16:creationId xmlns:a16="http://schemas.microsoft.com/office/drawing/2014/main" id="{EB2C58B4-4FEE-6F34-7CFC-58EEB02CACD7}"/>
+              </a:ext>
+            </a:extLst>
+          </p:cNvPr>
+          <p:cNvSpPr/>
+          <p:nvPr/>
+        </p:nvSpPr>
+        <p:spPr>
+          <a:xfrm>
+            <a:off x="6010657" y="3197219"/>
+            <a:ext cx="1371600" cy="1411550"/>
+          </a:xfrm>
+          <a:prstGeom prst="rect">
+            <a:avLst/>
+          </a:prstGeom>
+          <a:noFill/>
+          <a:ln>
+            <a:solidFill>
+              <a:schemeClr val="tx1"/>
+            </a:solidFill>
+          </a:ln>
+        </p:spPr>
+        <p:style>
+          <a:lnRef idx="2">
+            <a:schemeClr val="accent1">
+              <a:shade val="15000"/>
+            </a:schemeClr>
+          </a:lnRef>
+          <a:fillRef idx="1">
+            <a:schemeClr val="accent1"/>
+          </a:fillRef>
+          <a:effectRef idx="0">
+            <a:schemeClr val="accent1"/>
+          </a:effectRef>
+          <a:fontRef idx="minor">
+            <a:schemeClr val="lt1"/>
+          </a:fontRef>
+        </p:style>
+        <p:txBody>
+          <a:bodyPr rtlCol="0" anchor="ctr"/>
+          <a:lstStyle/>
+          <a:p>
+            <a:pPr algn="ctr"/>
+            <a:endParaRPr lang="en-US"/>
+          </a:p>
+        </p:txBody>
+      </p:sp>
+      <p:sp>
+        <p:nvSpPr>
+          <p:cNvPr id="37" name="Oval 36">
+            <a:extLst>
+              <a:ext uri="{FF2B5EF4-FFF2-40B4-BE49-F238E27FC236}">
+                <a16:creationId xmlns:a16="http://schemas.microsoft.com/office/drawing/2014/main" id="{5822C083-13CA-F3E9-30FF-54037F2B88ED}"/>
+              </a:ext>
+            </a:extLst>
+          </p:cNvPr>
+          <p:cNvSpPr/>
+          <p:nvPr/>
+        </p:nvSpPr>
+        <p:spPr>
+          <a:xfrm>
+            <a:off x="6318270" y="3552289"/>
+            <a:ext cx="274320" cy="274320"/>
+          </a:xfrm>
+          <a:prstGeom prst="ellipse">
+            <a:avLst/>
+          </a:prstGeom>
+          <a:noFill/>
+          <a:ln>
+            <a:solidFill>
+              <a:schemeClr val="tx1"/>
+            </a:solidFill>
+            <a:prstDash val="solid"/>
+          </a:ln>
+        </p:spPr>
+        <p:style>
+          <a:lnRef idx="2">
+            <a:schemeClr val="accent1">
+              <a:shade val="15000"/>
+            </a:schemeClr>
+          </a:lnRef>
+          <a:fillRef idx="1">
+            <a:schemeClr val="accent1"/>
+          </a:fillRef>
+          <a:effectRef idx="0">
+            <a:schemeClr val="accent1"/>
+          </a:effectRef>
+          <a:fontRef idx="minor">
+            <a:schemeClr val="lt1"/>
+          </a:fontRef>
+        </p:style>
+        <p:txBody>
+          <a:bodyPr rtlCol="0" anchor="ctr"/>
+          <a:lstStyle/>
+          <a:p>
+            <a:pPr algn="ctr"/>
+            <a:endParaRPr lang="en-US"/>
+          </a:p>
+        </p:txBody>
+      </p:sp>
+      <p:sp>
+        <p:nvSpPr>
+          <p:cNvPr id="39" name="Oval 38">
+            <a:extLst>
+              <a:ext uri="{FF2B5EF4-FFF2-40B4-BE49-F238E27FC236}">
+                <a16:creationId xmlns:a16="http://schemas.microsoft.com/office/drawing/2014/main" id="{E32441B1-9D1B-8BA8-8357-4D8325D5BC53}"/>
+              </a:ext>
+            </a:extLst>
+          </p:cNvPr>
+          <p:cNvSpPr/>
+          <p:nvPr/>
+        </p:nvSpPr>
+        <p:spPr>
+          <a:xfrm>
+            <a:off x="6318270" y="3956322"/>
+            <a:ext cx="274320" cy="274320"/>
+          </a:xfrm>
+          <a:prstGeom prst="ellipse">
+            <a:avLst/>
+          </a:prstGeom>
+          <a:noFill/>
+          <a:ln>
+            <a:solidFill>
+              <a:schemeClr val="tx1"/>
+            </a:solidFill>
+          </a:ln>
+        </p:spPr>
+        <p:style>
+          <a:lnRef idx="2">
+            <a:schemeClr val="accent1">
+              <a:shade val="15000"/>
+            </a:schemeClr>
+          </a:lnRef>
+          <a:fillRef idx="1">
+            <a:schemeClr val="accent1"/>
+          </a:fillRef>
+          <a:effectRef idx="0">
+            <a:schemeClr val="accent1"/>
+          </a:effectRef>
+          <a:fontRef idx="minor">
+            <a:schemeClr val="lt1"/>
+          </a:fontRef>
+        </p:style>
+        <p:txBody>
+          <a:bodyPr rtlCol="0" anchor="ctr"/>
+          <a:lstStyle/>
+          <a:p>
+            <a:pPr algn="ctr"/>
+            <a:endParaRPr lang="en-US"/>
+          </a:p>
+        </p:txBody>
+      </p:sp>
+      <p:sp>
+        <p:nvSpPr>
+          <p:cNvPr id="40" name="Oval 39">
+            <a:extLst>
+              <a:ext uri="{FF2B5EF4-FFF2-40B4-BE49-F238E27FC236}">
+                <a16:creationId xmlns:a16="http://schemas.microsoft.com/office/drawing/2014/main" id="{5F4C28D7-C3DA-CCEB-D7EF-D14BBB6CAF5F}"/>
+              </a:ext>
+            </a:extLst>
+          </p:cNvPr>
+          <p:cNvSpPr/>
+          <p:nvPr/>
+        </p:nvSpPr>
+        <p:spPr>
+          <a:xfrm>
+            <a:off x="6759145" y="3956322"/>
+            <a:ext cx="274320" cy="274320"/>
+          </a:xfrm>
+          <a:prstGeom prst="ellipse">
+            <a:avLst/>
+          </a:prstGeom>
+          <a:noFill/>
+          <a:ln>
+            <a:solidFill>
+              <a:schemeClr val="tx1"/>
+            </a:solidFill>
+          </a:ln>
+        </p:spPr>
+        <p:style>
+          <a:lnRef idx="2">
+            <a:schemeClr val="accent1">
+              <a:shade val="15000"/>
+            </a:schemeClr>
+          </a:lnRef>
+          <a:fillRef idx="1">
+            <a:schemeClr val="accent1"/>
+          </a:fillRef>
+          <a:effectRef idx="0">
+            <a:schemeClr val="accent1"/>
+          </a:effectRef>
+          <a:fontRef idx="minor">
+            <a:schemeClr val="lt1"/>
+          </a:fontRef>
+        </p:style>
+        <p:txBody>
+          <a:bodyPr rtlCol="0" anchor="ctr"/>
+          <a:lstStyle/>
+          <a:p>
+            <a:pPr algn="ctr"/>
+            <a:endParaRPr lang="en-US"/>
+          </a:p>
+        </p:txBody>
+      </p:sp>
+      <p:sp>
+        <p:nvSpPr>
+          <p:cNvPr id="41" name="Oval 40">
+            <a:extLst>
+              <a:ext uri="{FF2B5EF4-FFF2-40B4-BE49-F238E27FC236}">
+                <a16:creationId xmlns:a16="http://schemas.microsoft.com/office/drawing/2014/main" id="{C9450B3D-CD6D-08E6-1AEC-F549729A0F59}"/>
+              </a:ext>
+            </a:extLst>
+          </p:cNvPr>
+          <p:cNvSpPr/>
+          <p:nvPr/>
+        </p:nvSpPr>
+        <p:spPr>
+          <a:xfrm>
+            <a:off x="6759145" y="3552289"/>
+            <a:ext cx="274320" cy="274320"/>
+          </a:xfrm>
+          <a:prstGeom prst="ellipse">
+            <a:avLst/>
+          </a:prstGeom>
+          <a:noFill/>
+          <a:ln>
+            <a:solidFill>
+              <a:schemeClr val="tx1"/>
+            </a:solidFill>
+          </a:ln>
+        </p:spPr>
+        <p:style>
+          <a:lnRef idx="2">
+            <a:schemeClr val="accent1">
+              <a:shade val="15000"/>
+            </a:schemeClr>
+          </a:lnRef>
+          <a:fillRef idx="1">
+            <a:schemeClr val="accent1"/>
+          </a:fillRef>
+          <a:effectRef idx="0">
+            <a:schemeClr val="accent1"/>
+          </a:effectRef>
+          <a:fontRef idx="minor">
+            <a:schemeClr val="lt1"/>
+          </a:fontRef>
+        </p:style>
+        <p:txBody>
+          <a:bodyPr rtlCol="0" anchor="ctr"/>
+          <a:lstStyle/>
+          <a:p>
+            <a:pPr algn="ctr"/>
+            <a:endParaRPr lang="en-US"/>
+          </a:p>
+        </p:txBody>
+      </p:sp>
+      <p:sp>
+        <p:nvSpPr>
+          <p:cNvPr id="44" name="TextBox 43">
+            <a:extLst>
+              <a:ext uri="{FF2B5EF4-FFF2-40B4-BE49-F238E27FC236}">
+                <a16:creationId xmlns:a16="http://schemas.microsoft.com/office/drawing/2014/main" id="{2DBECBE0-A478-54B6-454D-37E574213398}"/>
+              </a:ext>
+            </a:extLst>
+          </p:cNvPr>
+          <p:cNvSpPr txBox="1"/>
+          <p:nvPr/>
+        </p:nvSpPr>
+        <p:spPr>
+          <a:xfrm>
+            <a:off x="1354875" y="2010899"/>
+            <a:ext cx="3307085" cy="369332"/>
+          </a:xfrm>
+          <a:prstGeom prst="rect">
+            <a:avLst/>
+          </a:prstGeom>
+          <a:noFill/>
+        </p:spPr>
+        <p:txBody>
+          <a:bodyPr wrap="square" rtlCol="0">
+            <a:spAutoFit/>
+          </a:bodyPr>
+          <a:lstStyle/>
+          <a:p>
+            <a:r>
+              <a:rPr lang="en-US" b="1" dirty="0"/>
+              <a:t>Scenario 1 </a:t>
+            </a:r>
+          </a:p>
+        </p:txBody>
+      </p:sp>
+      <p:sp>
+        <p:nvSpPr>
+          <p:cNvPr id="45" name="TextBox 44">
+            <a:extLst>
+              <a:ext uri="{FF2B5EF4-FFF2-40B4-BE49-F238E27FC236}">
+                <a16:creationId xmlns:a16="http://schemas.microsoft.com/office/drawing/2014/main" id="{F8E2F92F-BFCE-3D36-C2AC-713BFBA93EC2}"/>
+              </a:ext>
+            </a:extLst>
+          </p:cNvPr>
+          <p:cNvSpPr txBox="1"/>
+          <p:nvPr/>
+        </p:nvSpPr>
+        <p:spPr>
+          <a:xfrm>
+            <a:off x="6010657" y="1963213"/>
+            <a:ext cx="3307085" cy="369332"/>
+          </a:xfrm>
+          <a:prstGeom prst="rect">
+            <a:avLst/>
+          </a:prstGeom>
+          <a:noFill/>
+        </p:spPr>
+        <p:txBody>
+          <a:bodyPr wrap="square" rtlCol="0">
+            <a:spAutoFit/>
+          </a:bodyPr>
+          <a:lstStyle/>
+          <a:p>
+            <a:r>
+              <a:rPr lang="en-US" b="1" dirty="0"/>
+              <a:t>Scenario 2 </a:t>
+            </a:r>
+          </a:p>
+        </p:txBody>
+      </p:sp>
+      <p:sp>
+        <p:nvSpPr>
+          <p:cNvPr id="46" name="Rectangle 45">
+            <a:extLst>
+              <a:ext uri="{FF2B5EF4-FFF2-40B4-BE49-F238E27FC236}">
+                <a16:creationId xmlns:a16="http://schemas.microsoft.com/office/drawing/2014/main" id="{8C0D9843-398F-172C-1110-A340D4CB6609}"/>
+              </a:ext>
+            </a:extLst>
+          </p:cNvPr>
+          <p:cNvSpPr/>
+          <p:nvPr/>
+        </p:nvSpPr>
+        <p:spPr>
+          <a:xfrm>
+            <a:off x="1189513" y="2419792"/>
+            <a:ext cx="4365647" cy="2587464"/>
+          </a:xfrm>
+          <a:prstGeom prst="rect">
+            <a:avLst/>
+          </a:prstGeom>
+          <a:noFill/>
+          <a:ln>
+            <a:solidFill>
+              <a:schemeClr val="tx1"/>
+            </a:solidFill>
+          </a:ln>
+        </p:spPr>
+        <p:style>
+          <a:lnRef idx="2">
+            <a:schemeClr val="accent1">
+              <a:shade val="15000"/>
+            </a:schemeClr>
+          </a:lnRef>
+          <a:fillRef idx="1">
+            <a:schemeClr val="accent1"/>
+          </a:fillRef>
+          <a:effectRef idx="0">
+            <a:schemeClr val="accent1"/>
+          </a:effectRef>
+          <a:fontRef idx="minor">
+            <a:schemeClr val="lt1"/>
+          </a:fontRef>
+        </p:style>
+        <p:txBody>
+          <a:bodyPr rtlCol="0" anchor="ctr"/>
+          <a:lstStyle/>
+          <a:p>
+            <a:pPr algn="ctr"/>
+            <a:endParaRPr lang="en-US"/>
+          </a:p>
+        </p:txBody>
+      </p:sp>
+      <p:sp>
+        <p:nvSpPr>
+          <p:cNvPr id="47" name="Rectangle 46">
+            <a:extLst>
+              <a:ext uri="{FF2B5EF4-FFF2-40B4-BE49-F238E27FC236}">
+                <a16:creationId xmlns:a16="http://schemas.microsoft.com/office/drawing/2014/main" id="{AE6ABEB2-D92D-FD76-8FEB-4ED3763B892F}"/>
+              </a:ext>
+            </a:extLst>
+          </p:cNvPr>
+          <p:cNvSpPr/>
+          <p:nvPr/>
+        </p:nvSpPr>
+        <p:spPr>
+          <a:xfrm>
+            <a:off x="5551229" y="2419792"/>
+            <a:ext cx="5665411" cy="2587464"/>
+          </a:xfrm>
+          <a:prstGeom prst="rect">
+            <a:avLst/>
+          </a:prstGeom>
+          <a:noFill/>
+          <a:ln>
+            <a:solidFill>
+              <a:schemeClr val="tx1"/>
+            </a:solidFill>
+          </a:ln>
+        </p:spPr>
+        <p:style>
+          <a:lnRef idx="2">
+            <a:schemeClr val="accent1">
+              <a:shade val="15000"/>
+            </a:schemeClr>
+          </a:lnRef>
+          <a:fillRef idx="1">
+            <a:schemeClr val="accent1"/>
+          </a:fillRef>
+          <a:effectRef idx="0">
+            <a:schemeClr val="accent1"/>
+          </a:effectRef>
+          <a:fontRef idx="minor">
+            <a:schemeClr val="lt1"/>
+          </a:fontRef>
+        </p:style>
+        <p:txBody>
+          <a:bodyPr rtlCol="0" anchor="ctr"/>
+          <a:lstStyle/>
+          <a:p>
+            <a:pPr algn="ctr"/>
+            <a:endParaRPr lang="en-US"/>
+          </a:p>
+        </p:txBody>
+      </p:sp>
+    </p:spTree>
+    <p:extLst>
+      <p:ext uri="{BB962C8B-B14F-4D97-AF65-F5344CB8AC3E}">
+        <p14:creationId xmlns:p14="http://schemas.microsoft.com/office/powerpoint/2010/main" val="360424062"/>
+      </p:ext>
+    </p:extLst>
+  </p:cSld>
+  <p:clrMapOvr>
+    <a:masterClrMapping/>
+  </p:clrMapOvr>
+</p:sld>
+</file>
+
+<file path=ppt/slides/slide7.xml><?xml version="1.0" encoding="utf-8"?>
+<p:sld xmlns:a="http://schemas.openxmlformats.org/drawingml/2006/main" xmlns:r="http://schemas.openxmlformats.org/officeDocument/2006/relationships" xmlns:p="http://schemas.openxmlformats.org/presentationml/2006/main">
+  <p:cSld>
+    <p:spTree>
+      <p:nvGrpSpPr>
         <p:cNvPr id="1" name=""/>
         <p:cNvGrpSpPr/>
         <p:nvPr/>
@@ -12342,7 +14552,7 @@
 </p:sld>
 </file>
 
-<file path=ppt/slides/slide7.xml><?xml version="1.0" encoding="utf-8"?>
+<file path=ppt/slides/slide8.xml><?xml version="1.0" encoding="utf-8"?>
 <p:sld xmlns:a="http://schemas.openxmlformats.org/drawingml/2006/main" xmlns:r="http://schemas.openxmlformats.org/officeDocument/2006/relationships" xmlns:p="http://schemas.openxmlformats.org/presentationml/2006/main">
   <p:cSld>
     <p:spTree>
@@ -12557,7 +14767,7 @@
 </p:sld>
 </file>
 
-<file path=ppt/slides/slide8.xml><?xml version="1.0" encoding="utf-8"?>
+<file path=ppt/slides/slide9.xml><?xml version="1.0" encoding="utf-8"?>
 <p:sld xmlns:a="http://schemas.openxmlformats.org/drawingml/2006/main" xmlns:r="http://schemas.openxmlformats.org/officeDocument/2006/relationships" xmlns:p="http://schemas.openxmlformats.org/presentationml/2006/main">
   <p:cSld>
     <p:spTree>
@@ -12763,226 +14973,6 @@
     <p:extLst>
       <p:ext uri="{BB962C8B-B14F-4D97-AF65-F5344CB8AC3E}">
         <p14:creationId xmlns:p14="http://schemas.microsoft.com/office/powerpoint/2010/main" val="3142209363"/>
-      </p:ext>
-    </p:extLst>
-  </p:cSld>
-  <p:clrMapOvr>
-    <a:masterClrMapping/>
-  </p:clrMapOvr>
-</p:sld>
-</file>
-
-<file path=ppt/slides/slide9.xml><?xml version="1.0" encoding="utf-8"?>
-<p:sld xmlns:a="http://schemas.openxmlformats.org/drawingml/2006/main" xmlns:r="http://schemas.openxmlformats.org/officeDocument/2006/relationships" xmlns:p="http://schemas.openxmlformats.org/presentationml/2006/main">
-  <p:cSld>
-    <p:spTree>
-      <p:nvGrpSpPr>
-        <p:cNvPr id="1" name=""/>
-        <p:cNvGrpSpPr/>
-        <p:nvPr/>
-      </p:nvGrpSpPr>
-      <p:grpSpPr>
-        <a:xfrm>
-          <a:off x="0" y="0"/>
-          <a:ext cx="0" cy="0"/>
-          <a:chOff x="0" y="0"/>
-          <a:chExt cx="0" cy="0"/>
-        </a:xfrm>
-      </p:grpSpPr>
-      <p:pic>
-        <p:nvPicPr>
-          <p:cNvPr id="2" name="Picture 1">
-            <a:extLst>
-              <a:ext uri="{FF2B5EF4-FFF2-40B4-BE49-F238E27FC236}">
-                <a16:creationId xmlns:a16="http://schemas.microsoft.com/office/drawing/2014/main" id="{ABAE4FC8-574C-CC7A-A384-74DAF20ED743}"/>
-              </a:ext>
-            </a:extLst>
-          </p:cNvPr>
-          <p:cNvPicPr>
-            <a:picLocks noChangeAspect="1"/>
-          </p:cNvPicPr>
-          <p:nvPr/>
-        </p:nvPicPr>
-        <p:blipFill>
-          <a:blip r:embed="rId2"/>
-          <a:stretch>
-            <a:fillRect/>
-          </a:stretch>
-        </p:blipFill>
-        <p:spPr>
-          <a:xfrm>
-            <a:off x="1852816" y="2038991"/>
-            <a:ext cx="8486368" cy="2780017"/>
-          </a:xfrm>
-          <a:prstGeom prst="rect">
-            <a:avLst/>
-          </a:prstGeom>
-        </p:spPr>
-      </p:pic>
-      <mc:AlternateContent xmlns:mc="http://schemas.openxmlformats.org/markup-compatibility/2006" xmlns:a14="http://schemas.microsoft.com/office/drawing/2010/main">
-        <mc:Choice Requires="a14">
-          <p:sp>
-            <p:nvSpPr>
-              <p:cNvPr id="3" name="TextBox 2">
-                <a:extLst>
-                  <a:ext uri="{FF2B5EF4-FFF2-40B4-BE49-F238E27FC236}">
-                    <a16:creationId xmlns:a16="http://schemas.microsoft.com/office/drawing/2014/main" id="{8C943BC5-80E7-C591-97D0-21663D439FB8}"/>
-                  </a:ext>
-                </a:extLst>
-              </p:cNvPr>
-              <p:cNvSpPr txBox="1"/>
-              <p:nvPr/>
-            </p:nvSpPr>
-            <p:spPr>
-              <a:xfrm>
-                <a:off x="659561" y="1203559"/>
-                <a:ext cx="5293629" cy="553998"/>
-              </a:xfrm>
-              <a:prstGeom prst="rect">
-                <a:avLst/>
-              </a:prstGeom>
-              <a:noFill/>
-            </p:spPr>
-            <p:txBody>
-              <a:bodyPr wrap="none" lIns="0" tIns="0" rIns="0" bIns="0" rtlCol="0">
-                <a:spAutoFit/>
-              </a:bodyPr>
-              <a:lstStyle/>
-              <a:p>
-                <a14:m>
-                  <m:oMath xmlns:m="http://schemas.openxmlformats.org/officeDocument/2006/math">
-                    <m:sSub>
-                      <m:sSubPr>
-                        <m:ctrlPr>
-                          <a:rPr lang="en-US" sz="3600" b="0" i="1" smtClean="0">
-                            <a:latin typeface="Cambria Math" panose="02040503050406030204" pitchFamily="18" charset="0"/>
-                          </a:rPr>
-                        </m:ctrlPr>
-                      </m:sSubPr>
-                      <m:e>
-                        <m:r>
-                          <a:rPr lang="en-US" sz="3600" b="0" i="1" smtClean="0">
-                            <a:latin typeface="Cambria Math" panose="02040503050406030204" pitchFamily="18" charset="0"/>
-                          </a:rPr>
-                          <m:t>𝑚</m:t>
-                        </m:r>
-                      </m:e>
-                      <m:sub>
-                        <m:r>
-                          <a:rPr lang="en-US" sz="3600" b="0" i="1" smtClean="0">
-                            <a:latin typeface="Cambria Math" panose="02040503050406030204" pitchFamily="18" charset="0"/>
-                          </a:rPr>
-                          <m:t>𝑘</m:t>
-                        </m:r>
-                        <m:r>
-                          <a:rPr lang="en-US" sz="3600" b="0" i="1" smtClean="0">
-                            <a:latin typeface="Cambria Math" panose="02040503050406030204" pitchFamily="18" charset="0"/>
-                          </a:rPr>
-                          <m:t>+1</m:t>
-                        </m:r>
-                      </m:sub>
-                    </m:sSub>
-                    <m:r>
-                      <a:rPr lang="en-US" sz="3600" b="0" i="1" smtClean="0">
-                        <a:latin typeface="Cambria Math" panose="02040503050406030204" pitchFamily="18" charset="0"/>
-                      </a:rPr>
-                      <m:t>&lt;</m:t>
-                    </m:r>
-                    <m:sSub>
-                      <m:sSubPr>
-                        <m:ctrlPr>
-                          <a:rPr lang="en-US" sz="3600" b="0" i="1" smtClean="0">
-                            <a:latin typeface="Cambria Math" panose="02040503050406030204" pitchFamily="18" charset="0"/>
-                          </a:rPr>
-                        </m:ctrlPr>
-                      </m:sSubPr>
-                      <m:e>
-                        <m:r>
-                          <a:rPr lang="en-US" sz="3600" b="0" i="1" smtClean="0">
-                            <a:latin typeface="Cambria Math" panose="02040503050406030204" pitchFamily="18" charset="0"/>
-                          </a:rPr>
-                          <m:t>𝑚</m:t>
-                        </m:r>
-                      </m:e>
-                      <m:sub>
-                        <m:r>
-                          <a:rPr lang="en-US" sz="3600" b="0" i="1" smtClean="0">
-                            <a:latin typeface="Cambria Math" panose="02040503050406030204" pitchFamily="18" charset="0"/>
-                          </a:rPr>
-                          <m:t>𝑘</m:t>
-                        </m:r>
-                      </m:sub>
-                    </m:sSub>
-                    <m:r>
-                      <a:rPr lang="en-US" sz="3600" b="0" i="1" smtClean="0">
-                        <a:latin typeface="Cambria Math" panose="02040503050406030204" pitchFamily="18" charset="0"/>
-                      </a:rPr>
-                      <m:t>−1</m:t>
-                    </m:r>
-                  </m:oMath>
-                </a14:m>
-                <a:r>
-                  <a:rPr lang="en-US" sz="3600" dirty="0"/>
-                  <a:t> </a:t>
-                </a:r>
-                <a:r>
-                  <a:rPr lang="en-US" sz="3600"/>
-                  <a:t>(figure 1.5)</a:t>
-                </a:r>
-                <a:endParaRPr lang="en-US" sz="3600" dirty="0"/>
-              </a:p>
-            </p:txBody>
-          </p:sp>
-        </mc:Choice>
-        <mc:Fallback xmlns="">
-          <p:sp>
-            <p:nvSpPr>
-              <p:cNvPr id="3" name="TextBox 2">
-                <a:extLst>
-                  <a:ext uri="{FF2B5EF4-FFF2-40B4-BE49-F238E27FC236}">
-                    <a16:creationId xmlns:a16="http://schemas.microsoft.com/office/drawing/2014/main" id="{8C943BC5-80E7-C591-97D0-21663D439FB8}"/>
-                  </a:ext>
-                </a:extLst>
-              </p:cNvPr>
-              <p:cNvSpPr txBox="1">
-                <a:spLocks noRot="1" noChangeAspect="1" noMove="1" noResize="1" noEditPoints="1" noAdjustHandles="1" noChangeArrowheads="1" noChangeShapeType="1" noTextEdit="1"/>
-              </p:cNvSpPr>
-              <p:nvPr/>
-            </p:nvSpPr>
-            <p:spPr>
-              <a:xfrm>
-                <a:off x="659561" y="1203559"/>
-                <a:ext cx="5293629" cy="553998"/>
-              </a:xfrm>
-              <a:prstGeom prst="rect">
-                <a:avLst/>
-              </a:prstGeom>
-              <a:blipFill>
-                <a:blip r:embed="rId3"/>
-                <a:stretch>
-                  <a:fillRect t="-24176" r="-4143" b="-50549"/>
-                </a:stretch>
-              </a:blipFill>
-            </p:spPr>
-            <p:txBody>
-              <a:bodyPr/>
-              <a:lstStyle/>
-              <a:p>
-                <a:r>
-                  <a:rPr lang="en-US">
-                    <a:noFill/>
-                  </a:rPr>
-                  <a:t> </a:t>
-                </a:r>
-              </a:p>
-            </p:txBody>
-          </p:sp>
-        </mc:Fallback>
-      </mc:AlternateContent>
-    </p:spTree>
-    <p:extLst>
-      <p:ext uri="{BB962C8B-B14F-4D97-AF65-F5344CB8AC3E}">
-        <p14:creationId xmlns:p14="http://schemas.microsoft.com/office/powerpoint/2010/main" val="2681676662"/>
       </p:ext>
     </p:extLst>
   </p:cSld>

</xml_diff>